<commit_message>
Rewrite the four findings and add the logic backup
Each finding now answers every part of its question: Q1 covers CAR and abnormal volume, Q2 covers upgrades and downgrades, Q3 covers holding returns and forecast errors, and Q4 states the small-tier constraint. Adds a Chinese logic and speaking backup for the four findings.

Co-Authored-By: Claude Fable 5.1 <noreply@anthropic.com>
</commit_message>
<xml_diff>
--- a/文档/Project10_Star_Analyst_Deck_20261027.pptx
+++ b/文档/Project10_Star_Analyst_Deck_20261027.pptx
@@ -586,7 +586,7 @@
           <a:lstStyle/>
           <a:p>
             <a:r>
-              <a:t>持有收益只在短期站得住：上调 6 个月多 1.51，下调 3 个月多 1.78，12 个月都不显著。预测误差方向相反，四个格子明星都更大，FY1 下调差 0.94，p 小于 0.001。符号误差没有显著差异，所以不是更乐观，而是更分散。明星可能覆盖更难的公司，这个选择效应控制不了，只当描述性证据。</a:t>
+              <a:t>Q3 有两个准确度指标，必须同时回答。持有收益短期支持明星：上调 6 个月多 1.51，p=0.048；下调 3 个月多 1.78，p=0.001；但 12 个月都不显著。预测误差方向相反，四个格子明星都更大，FY1 下调差 0.94，p 小于 0.001。所以答案是短期有一点持有收益优势，但没有稳定的预测准确度优势。符号误差没有显著差异，不是更乐观，而是更分散。</a:t>
             </a:r>
           </a:p>
         </p:txBody>
@@ -656,7 +656,7 @@
           <a:lstStyle/>
           <a:p>
             <a:r>
-              <a:t>方向不对称在五日窗口和成交量上最清楚。层级看起来有故事，但滚动层级 23.1% 的事件换层后，头部上调还在，中部下调掉到 0.33，不显著。层级只能当描述，不能当因果渠道。</a:t>
+              <a:t>Q4 有两半：方向和券商层级。方向是不对称的，五日窗口上调 +0.58，和下调的交互 -0.70，成交量交互 -0.057，都显著。层级看起来有故事，但滚动层级 23.1% 的事件换层后，头部上调还在，中部下调掉到 0.33，不显著。小层级只有 2 条明星上调、0 条下调，无法估计。所以层级只能当描述，不能当因果渠道。</a:t>
             </a:r>
           </a:p>
         </p:txBody>
@@ -1356,7 +1356,7 @@
           <a:lstStyle/>
           <a:p>
             <a:r>
-              <a:t>明星上调三日多 0.37 个百分点，十一日多 0.99，异常成交量高 0.053 个对数点。经济幅度不大，但估计精确。明星下调三个窗口都不显著。同股同日先取均值，结果更大，说明不是同日重复事件堆出来的。</a:t>
+              <a:t>Q1 有两半：收益和成交量；每一半又要分上调和下调。明星上调的 CAR 是 +0.37，t=2.17；异常成交量是 +0.053 个对数点，t=2.85，约等于成交量高 5%。明星下调的 CAR 是 +0.06，t=0.35；成交量是 -0.011，t=-0.53，两个都不显著。所以 Q1 的答案是四个格子里只有上调的两个格子动了。</a:t>
             </a:r>
           </a:p>
         </p:txBody>
@@ -1426,7 +1426,7 @@
           <a:lstStyle/>
           <a:p>
             <a:r>
-              <a:t>剔除窗口内出现涨跌停的事件：三日 0.37 降到 0.21，不显著；五日 0.54 降到 0.20，不显著；十一日 0.99 还剩 0.65，仍显著。短窗口显著性不能说是稳健的。这是边界，不是藏起来的失败。</a:t>
+              <a:t>这一页只检验 CAR 的边界，不检验成交量。剔除窗口内出现涨跌停的事件：三日 0.37 降到 0.21，不显著；五日 0.54 降到 0.20，不显著；十一日 0.99 还剩 0.65，仍显著。短窗口 CAR 显著性不能说是稳健的。成交量没有做同样的剔除，页面上要讲清楚。</a:t>
             </a:r>
           </a:p>
         </p:txBody>
@@ -1496,7 +1496,7 @@
           <a:lstStyle/>
           <a:p>
             <a:r>
-              <a:t>漂移从 +2 开始算，不是公告日反应本身。明星下调前 60 个交易日继续跑输 1.64 个百分点，统计显著；到 120 日缩小到 0.76，不显著；到 250 日变成 +1.53，也不显著。这个形态更像延迟反应之后的部分反转。明星上调没有差异化漂移。</a:t>
+              <a:t>Q2 要同时回答上调和下调。下调在 +2 到 +60 继续跑输 1.64，p=0.002；到 +120 缩小到 0.76，不显著；到 +250 变成 +1.53，也不显著。上调三个窗口都不显著。这个形态更像延迟反应之后的部分反转，不能说是过度反应，因为下调的公告日反应本身并不比非明星大。</a:t>
             </a:r>
           </a:p>
         </p:txBody>
@@ -5132,7 +5132,7 @@
                 </a:solidFill>
                 <a:latin typeface="Times New Roman"/>
               </a:rPr>
-              <a:t>FINDING 3 · ARE STARS MORE ACCURATE?</a:t>
+              <a:t>FINDING 3 · Q3 · MORE ACCURATE OR JUST INFLUENTIAL?</a:t>
             </a:r>
           </a:p>
         </p:txBody>
@@ -5174,8 +5174,8 @@
                 </a:solidFill>
                 <a:latin typeface="Times New Roman"/>
               </a:rPr>
-              <a:t>Stars are not better forecasters.
-Their absolute errors are larger in every cell.</a:t>
+              <a:t>Stars show a short-lived return edge,
+not better forecasts.</a:t>
             </a:r>
           </a:p>
         </p:txBody>
@@ -5299,9 +5299,93 @@
           </a:p>
         </p:txBody>
       </p:sp>
+      <p:sp>
+        <p:nvSpPr>
+          <p:cNvPr id="7" name="TextBox 6"/>
+          <p:cNvSpPr txBox="1"/>
+          <p:nvPr/>
+        </p:nvSpPr>
+        <p:spPr>
+          <a:xfrm>
+            <a:off x="640080" y="1572768"/>
+            <a:ext cx="5669280" cy="201168"/>
+          </a:xfrm>
+          <a:prstGeom prst="rect">
+            <a:avLst/>
+          </a:prstGeom>
+          <a:noFill/>
+        </p:spPr>
+        <p:txBody>
+          <a:bodyPr wrap="square" lIns="0" rIns="0" tIns="0" bIns="0" anchor="t">
+            <a:noAutofit/>
+          </a:bodyPr>
+          <a:lstStyle/>
+          <a:p>
+            <a:pPr algn="l">
+              <a:lnSpc>
+                <a:spcPct val="100000"/>
+              </a:lnSpc>
+              <a:spcAft>
+                <a:spcPts val="0"/>
+              </a:spcAft>
+            </a:pPr>
+            <a:r>
+              <a:rPr sz="1282" b="1" i="0" spc="50">
+                <a:solidFill>
+                  <a:srgbClr val="6B7280"/>
+                </a:solidFill>
+                <a:latin typeface="Times New Roman"/>
+              </a:rPr>
+              <a:t>HOLDING RETURNS (STAR MINUS NON-STAR)</a:t>
+            </a:r>
+          </a:p>
+        </p:txBody>
+      </p:sp>
+      <p:sp>
+        <p:nvSpPr>
+          <p:cNvPr id="8" name="TextBox 7"/>
+          <p:cNvSpPr txBox="1"/>
+          <p:nvPr/>
+        </p:nvSpPr>
+        <p:spPr>
+          <a:xfrm>
+            <a:off x="6675120" y="1572768"/>
+            <a:ext cx="4754880" cy="201168"/>
+          </a:xfrm>
+          <a:prstGeom prst="rect">
+            <a:avLst/>
+          </a:prstGeom>
+          <a:noFill/>
+        </p:spPr>
+        <p:txBody>
+          <a:bodyPr wrap="square" lIns="0" rIns="0" tIns="0" bIns="0" anchor="t">
+            <a:noAutofit/>
+          </a:bodyPr>
+          <a:lstStyle/>
+          <a:p>
+            <a:pPr algn="l">
+              <a:lnSpc>
+                <a:spcPct val="100000"/>
+              </a:lnSpc>
+              <a:spcAft>
+                <a:spcPts val="0"/>
+              </a:spcAft>
+            </a:pPr>
+            <a:r>
+              <a:rPr sz="1282" b="1" i="0" spc="50">
+                <a:solidFill>
+                  <a:srgbClr val="6B7280"/>
+                </a:solidFill>
+                <a:latin typeface="Times New Roman"/>
+              </a:rPr>
+              <a:t>FORECAST ERRORS (STAR MINUS NON-STAR)</a:t>
+            </a:r>
+          </a:p>
+        </p:txBody>
+      </p:sp>
       <p:pic>
         <p:nvPicPr>
-          <p:cNvPr id="7" name="Picture 6" descr="Bar chart of direction-adjusted holding returns for upgrades and downgrades"/>
+          <p:cNvPr id="9" name="Picture 8" descr="Bar chart of direction-adjusted holding returns for upgrades and downgrades"/>
           <p:cNvPicPr>
             <a:picLocks noChangeAspect="1"/>
           </p:cNvPicPr>
@@ -5315,7 +5399,7 @@
         </p:blipFill>
         <p:spPr>
           <a:xfrm>
-            <a:off x="640080" y="1737360"/>
+            <a:off x="640080" y="1783080"/>
             <a:ext cx="5806440" cy="3767328"/>
           </a:xfrm>
           <a:prstGeom prst="rect">
@@ -5325,7 +5409,7 @@
       </p:pic>
       <p:sp>
         <p:nvSpPr>
-          <p:cNvPr id="8" name="Rectangle 7"/>
+          <p:cNvPr id="10" name="Rectangle 9"/>
           <p:cNvSpPr/>
           <p:nvPr/>
         </p:nvSpPr>
@@ -5369,7 +5453,7 @@
       </p:sp>
       <p:sp>
         <p:nvSpPr>
-          <p:cNvPr id="9" name="Rectangle 8"/>
+          <p:cNvPr id="11" name="Rectangle 10"/>
           <p:cNvSpPr/>
           <p:nvPr/>
         </p:nvSpPr>
@@ -5413,7 +5497,7 @@
       </p:sp>
       <p:sp>
         <p:nvSpPr>
-          <p:cNvPr id="10" name="TextBox 9"/>
+          <p:cNvPr id="12" name="TextBox 11"/>
           <p:cNvSpPr txBox="1"/>
           <p:nvPr/>
         </p:nvSpPr>
@@ -5455,7 +5539,7 @@
       </p:sp>
       <p:sp>
         <p:nvSpPr>
-          <p:cNvPr id="11" name="TextBox 10"/>
+          <p:cNvPr id="13" name="TextBox 12"/>
           <p:cNvSpPr txBox="1"/>
           <p:nvPr/>
         </p:nvSpPr>
@@ -5497,7 +5581,7 @@
       </p:sp>
       <p:sp>
         <p:nvSpPr>
-          <p:cNvPr id="12" name="TextBox 11"/>
+          <p:cNvPr id="14" name="TextBox 13"/>
           <p:cNvSpPr txBox="1"/>
           <p:nvPr/>
         </p:nvSpPr>
@@ -5539,7 +5623,7 @@
       </p:sp>
       <p:sp>
         <p:nvSpPr>
-          <p:cNvPr id="13" name="Rectangle 12"/>
+          <p:cNvPr id="15" name="Rectangle 14"/>
           <p:cNvSpPr/>
           <p:nvPr/>
         </p:nvSpPr>
@@ -5583,7 +5667,7 @@
       </p:sp>
       <p:sp>
         <p:nvSpPr>
-          <p:cNvPr id="14" name="Rectangle 13"/>
+          <p:cNvPr id="16" name="Rectangle 15"/>
           <p:cNvSpPr/>
           <p:nvPr/>
         </p:nvSpPr>
@@ -5627,7 +5711,7 @@
       </p:sp>
       <p:sp>
         <p:nvSpPr>
-          <p:cNvPr id="15" name="TextBox 14"/>
+          <p:cNvPr id="17" name="TextBox 16"/>
           <p:cNvSpPr txBox="1"/>
           <p:nvPr/>
         </p:nvSpPr>
@@ -5669,7 +5753,7 @@
       </p:sp>
       <p:sp>
         <p:nvSpPr>
-          <p:cNvPr id="16" name="TextBox 15"/>
+          <p:cNvPr id="18" name="TextBox 17"/>
           <p:cNvSpPr txBox="1"/>
           <p:nvPr/>
         </p:nvSpPr>
@@ -5711,7 +5795,7 @@
       </p:sp>
       <p:sp>
         <p:nvSpPr>
-          <p:cNvPr id="17" name="TextBox 16"/>
+          <p:cNvPr id="19" name="TextBox 18"/>
           <p:cNvSpPr txBox="1"/>
           <p:nvPr/>
         </p:nvSpPr>
@@ -5753,7 +5837,7 @@
       </p:sp>
       <p:sp>
         <p:nvSpPr>
-          <p:cNvPr id="18" name="Rectangle 17"/>
+          <p:cNvPr id="20" name="Rectangle 19"/>
           <p:cNvSpPr/>
           <p:nvPr/>
         </p:nvSpPr>
@@ -5797,7 +5881,7 @@
       </p:sp>
       <p:sp>
         <p:nvSpPr>
-          <p:cNvPr id="19" name="Rectangle 18"/>
+          <p:cNvPr id="21" name="Rectangle 20"/>
           <p:cNvSpPr/>
           <p:nvPr/>
         </p:nvSpPr>
@@ -5841,7 +5925,7 @@
       </p:sp>
       <p:sp>
         <p:nvSpPr>
-          <p:cNvPr id="20" name="TextBox 19"/>
+          <p:cNvPr id="22" name="TextBox 21"/>
           <p:cNvSpPr txBox="1"/>
           <p:nvPr/>
         </p:nvSpPr>
@@ -5883,7 +5967,7 @@
       </p:sp>
       <p:sp>
         <p:nvSpPr>
-          <p:cNvPr id="21" name="TextBox 20"/>
+          <p:cNvPr id="23" name="TextBox 22"/>
           <p:cNvSpPr txBox="1"/>
           <p:nvPr/>
         </p:nvSpPr>
@@ -5925,7 +6009,7 @@
       </p:sp>
       <p:sp>
         <p:nvSpPr>
-          <p:cNvPr id="22" name="TextBox 21"/>
+          <p:cNvPr id="24" name="TextBox 23"/>
           <p:cNvSpPr txBox="1"/>
           <p:nvPr/>
         </p:nvSpPr>
@@ -5967,7 +6051,7 @@
       </p:sp>
       <p:sp>
         <p:nvSpPr>
-          <p:cNvPr id="23" name="Rectangle 22"/>
+          <p:cNvPr id="25" name="Rectangle 24"/>
           <p:cNvSpPr/>
           <p:nvPr/>
         </p:nvSpPr>
@@ -6011,7 +6095,7 @@
       </p:sp>
       <p:sp>
         <p:nvSpPr>
-          <p:cNvPr id="24" name="Rectangle 23"/>
+          <p:cNvPr id="26" name="Rectangle 25"/>
           <p:cNvSpPr/>
           <p:nvPr/>
         </p:nvSpPr>
@@ -6055,7 +6139,7 @@
       </p:sp>
       <p:sp>
         <p:nvSpPr>
-          <p:cNvPr id="25" name="TextBox 24"/>
+          <p:cNvPr id="27" name="TextBox 26"/>
           <p:cNvSpPr txBox="1"/>
           <p:nvPr/>
         </p:nvSpPr>
@@ -6097,7 +6181,7 @@
       </p:sp>
       <p:sp>
         <p:nvSpPr>
-          <p:cNvPr id="26" name="TextBox 25"/>
+          <p:cNvPr id="28" name="TextBox 27"/>
           <p:cNvSpPr txBox="1"/>
           <p:nvPr/>
         </p:nvSpPr>
@@ -6139,7 +6223,7 @@
       </p:sp>
       <p:sp>
         <p:nvSpPr>
-          <p:cNvPr id="27" name="TextBox 26"/>
+          <p:cNvPr id="29" name="TextBox 28"/>
           <p:cNvSpPr txBox="1"/>
           <p:nvPr/>
         </p:nvSpPr>
@@ -6181,49 +6265,92 @@
       </p:sp>
       <p:sp>
         <p:nvSpPr>
-          <p:cNvPr id="28" name="TextBox 27"/>
+          <p:cNvPr id="30" name="TextBox 29"/>
           <p:cNvSpPr txBox="1"/>
           <p:nvPr/>
         </p:nvSpPr>
         <p:spPr>
           <a:xfrm>
             <a:off x="6675120" y="4754880"/>
-            <a:ext cx="4754880" cy="914400"/>
-          </a:xfrm>
-          <a:prstGeom prst="rect">
-            <a:avLst/>
-          </a:prstGeom>
-          <a:noFill/>
-        </p:spPr>
-        <p:txBody>
-          <a:bodyPr wrap="square" lIns="0" rIns="0" tIns="0" bIns="0" anchor="t">
-            <a:noAutofit/>
-          </a:bodyPr>
-          <a:lstStyle/>
-          <a:p>
-            <a:pPr algn="l">
-              <a:lnSpc>
-                <a:spcPct val="106000"/>
-              </a:lnSpc>
-              <a:spcAft>
-                <a:spcPts val="0"/>
-              </a:spcAft>
-            </a:pPr>
-            <a:r>
-              <a:rPr sz="1417" b="0" i="0">
+            <a:ext cx="4754880" cy="1097280"/>
+          </a:xfrm>
+          <a:prstGeom prst="rect">
+            <a:avLst/>
+          </a:prstGeom>
+          <a:noFill/>
+        </p:spPr>
+        <p:txBody>
+          <a:bodyPr wrap="square" lIns="0" rIns="0" tIns="0" bIns="0" anchor="t">
+            <a:noAutofit/>
+          </a:bodyPr>
+          <a:lstStyle/>
+          <a:p>
+            <a:pPr algn="l">
+              <a:lnSpc>
+                <a:spcPct val="105000"/>
+              </a:lnSpc>
+              <a:spcAft>
+                <a:spcPts val="0"/>
+              </a:spcAft>
+            </a:pPr>
+            <a:r>
+              <a:rPr sz="1282" b="0" i="0">
                 <a:solidFill>
                   <a:srgbClr val="1F2A44"/>
                 </a:solidFill>
                 <a:latin typeface="Times New Roman"/>
               </a:rPr>
-              <a:t>Holding returns: +1.51 at 6m for upgrades (p = 0.048); +1.78 at 3m for downgrades (p = 0.001). No 12m persistence.</a:t>
-            </a:r>
-          </a:p>
-        </p:txBody>
-      </p:sp>
-      <p:sp>
-        <p:nvSpPr>
-          <p:cNvPr id="29" name="TextBox 28"/>
+              <a:t>Holding returns: +1.51 at 6m (up, p=.048); +1.78 at 3m (down, p=.001); no 12m persistence.
+Forecast errors: larger in all four cells.</a:t>
+            </a:r>
+          </a:p>
+        </p:txBody>
+      </p:sp>
+      <p:sp>
+        <p:nvSpPr>
+          <p:cNvPr id="31" name="TextBox 30"/>
+          <p:cNvSpPr txBox="1"/>
+          <p:nvPr/>
+        </p:nvSpPr>
+        <p:spPr>
+          <a:xfrm>
+            <a:off x="640080" y="5760720"/>
+            <a:ext cx="10881360" cy="320040"/>
+          </a:xfrm>
+          <a:prstGeom prst="rect">
+            <a:avLst/>
+          </a:prstGeom>
+          <a:noFill/>
+        </p:spPr>
+        <p:txBody>
+          <a:bodyPr wrap="square" lIns="0" rIns="0" tIns="0" bIns="0" anchor="t">
+            <a:noAutofit/>
+          </a:bodyPr>
+          <a:lstStyle/>
+          <a:p>
+            <a:pPr algn="l">
+              <a:lnSpc>
+                <a:spcPct val="100000"/>
+              </a:lnSpc>
+              <a:spcAft>
+                <a:spcPts val="0"/>
+              </a:spcAft>
+            </a:pPr>
+            <a:r>
+              <a:rPr sz="1620" b="1" i="0">
+                <a:solidFill>
+                  <a:srgbClr val="B23A2B"/>
+                </a:solidFill>
+                <a:latin typeface="Times New Roman"/>
+              </a:rPr>
+              <a:t>A short-lived return edge, not a stable accuracy advantage.</a:t>
+            </a:r>
+          </a:p>
+        </p:txBody>
+      </p:sp>
+      <p:sp>
+        <p:nvSpPr>
+          <p:cNvPr id="32" name="TextBox 31"/>
           <p:cNvSpPr txBox="1"/>
           <p:nvPr/>
         </p:nvSpPr>
@@ -6258,7 +6385,7 @@
                 </a:solidFill>
                 <a:latin typeface="Times New Roman"/>
               </a:rPr>
-              <a:t>Source: iFinD; authors' calculations. Forecast error is the absolute error as a percentage of the event-day price, winsorised at 1/99.</a:t>
+              <a:t>Source: iFinD; authors' calculations. Holding returns market-adjusted; forecast error winsorised at 1/99.</a:t>
             </a:r>
           </a:p>
         </p:txBody>
@@ -6318,7 +6445,7 @@
                 </a:solidFill>
                 <a:latin typeface="Times New Roman"/>
               </a:rPr>
-              <a:t>FINDING 4 · IS AUTHORITY ONE PREMIUM OR MANY?</a:t>
+              <a:t>FINDING 4 · Q4 · DOES THE PREMIUM VARY?</a:t>
             </a:r>
           </a:p>
         </p:txBody>
@@ -6361,7 +6488,7 @@
                 <a:latin typeface="Times New Roman"/>
               </a:rPr>
               <a:t>The premium is one-sided.
-Tier is not a stable channel.</a:t>
+Tier differences are not stable.</a:t>
             </a:r>
           </a:p>
         </p:txBody>
@@ -7578,23 +7705,23 @@
         </p:nvSpPr>
         <p:spPr>
           <a:xfrm>
-            <a:off x="640080" y="5486400"/>
-            <a:ext cx="10881360" cy="256032"/>
-          </a:xfrm>
-          <a:prstGeom prst="rect">
-            <a:avLst/>
-          </a:prstGeom>
-          <a:noFill/>
-        </p:spPr>
-        <p:txBody>
-          <a:bodyPr wrap="square" lIns="0" rIns="0" tIns="0" bIns="0" anchor="t">
-            <a:noAutofit/>
-          </a:bodyPr>
-          <a:lstStyle/>
-          <a:p>
-            <a:pPr algn="l">
-              <a:lnSpc>
-                <a:spcPct val="100000"/>
+            <a:off x="640080" y="5394960"/>
+            <a:ext cx="10881360" cy="502920"/>
+          </a:xfrm>
+          <a:prstGeom prst="rect">
+            <a:avLst/>
+          </a:prstGeom>
+          <a:noFill/>
+        </p:spPr>
+        <p:txBody>
+          <a:bodyPr wrap="square" lIns="0" rIns="0" tIns="0" bIns="0" anchor="t">
+            <a:noAutofit/>
+          </a:bodyPr>
+          <a:lstStyle/>
+          <a:p>
+            <a:pPr algn="l">
+              <a:lnSpc>
+                <a:spcPct val="110000"/>
               </a:lnSpc>
               <a:spcAft>
                 <a:spcPts val="0"/>
@@ -7607,7 +7734,8 @@
                 </a:solidFill>
                 <a:latin typeface="Times New Roman"/>
               </a:rPr>
-              <a:t>Regression estimates with controls; raw differences are in Finding 1.</a:t>
+              <a:t>Regression estimates with controls; raw differences are in Finding 1.
+Small tier: 2 star upgrades, 0 star downgrades; excluded from interaction models.</a:t>
             </a:r>
           </a:p>
         </p:txBody>
@@ -7620,8 +7748,8 @@
         </p:nvSpPr>
         <p:spPr>
           <a:xfrm>
-            <a:off x="640080" y="5779008"/>
-            <a:ext cx="10881360" cy="411480"/>
+            <a:off x="640080" y="5943600"/>
+            <a:ext cx="10881360" cy="365760"/>
           </a:xfrm>
           <a:prstGeom prst="rect">
             <a:avLst/>
@@ -10894,7 +11022,7 @@
                 </a:solidFill>
                 <a:latin typeface="Times New Roman"/>
               </a:rPr>
-              <a:t>Q&amp;A map: data source, event definition, endogeneity, alternatives, multiple testing.</a:t>
+              <a:t>Q&amp;A map: Q1 7-8; Q2 9; Q3 10; Q4 11. Data source, event definition, endogeneity, alternatives, multiple testing.</a:t>
             </a:r>
           </a:p>
         </p:txBody>
@@ -16456,7 +16584,7 @@
                 </a:solidFill>
                 <a:latin typeface="Times New Roman"/>
               </a:rPr>
-              <a:t>FINDING 1 · DO STAR REVISIONS MOVE THE MARKET?</a:t>
+              <a:t>FINDING 1 · Q1 · RETURNS AND VOLUME</a:t>
             </a:r>
           </a:p>
         </p:txBody>
@@ -16498,8 +16626,8 @@
                 </a:solidFill>
                 <a:latin typeface="Times New Roman"/>
               </a:rPr>
-              <a:t>Star upgrades earn a larger premium.
-Star downgrades do not.</a:t>
+              <a:t>Star upgrades move both price and volume.
+Star downgrades move neither.</a:t>
             </a:r>
           </a:p>
         </p:txBody>
@@ -16623,40 +16751,100 @@
           </a:p>
         </p:txBody>
       </p:sp>
-      <p:pic>
-        <p:nvPicPr>
-          <p:cNvPr id="7" name="Picture 6" descr="Bar chart of star minus non-star CAR for upgrades and downgrades"/>
-          <p:cNvPicPr>
-            <a:picLocks noChangeAspect="1"/>
-          </p:cNvPicPr>
-          <p:nvPr/>
-        </p:nvPicPr>
-        <p:blipFill>
-          <a:blip r:embed="rId2"/>
-          <a:stretch>
-            <a:fillRect/>
-          </a:stretch>
-        </p:blipFill>
-        <p:spPr>
-          <a:xfrm>
-            <a:off x="640080" y="1737360"/>
-            <a:ext cx="6446520" cy="4160520"/>
-          </a:xfrm>
-          <a:prstGeom prst="rect">
-            <a:avLst/>
-          </a:prstGeom>
-        </p:spPr>
-      </p:pic>
-      <p:sp>
-        <p:nvSpPr>
-          <p:cNvPr id="8" name="Rectangle 7"/>
+      <p:sp>
+        <p:nvSpPr>
+          <p:cNvPr id="7" name="TextBox 6"/>
+          <p:cNvSpPr txBox="1"/>
+          <p:nvPr/>
+        </p:nvSpPr>
+        <p:spPr>
+          <a:xfrm>
+            <a:off x="1828800" y="1627632"/>
+            <a:ext cx="4389120" cy="201168"/>
+          </a:xfrm>
+          <a:prstGeom prst="rect">
+            <a:avLst/>
+          </a:prstGeom>
+          <a:noFill/>
+        </p:spPr>
+        <p:txBody>
+          <a:bodyPr wrap="square" lIns="0" rIns="0" tIns="0" bIns="0" anchor="t">
+            <a:noAutofit/>
+          </a:bodyPr>
+          <a:lstStyle/>
+          <a:p>
+            <a:pPr algn="ctr">
+              <a:lnSpc>
+                <a:spcPct val="100000"/>
+              </a:lnSpc>
+              <a:spcAft>
+                <a:spcPts val="0"/>
+              </a:spcAft>
+            </a:pPr>
+            <a:r>
+              <a:rPr sz="1350" b="1" i="0" spc="80">
+                <a:solidFill>
+                  <a:srgbClr val="6B7280"/>
+                </a:solidFill>
+                <a:latin typeface="Times New Roman"/>
+              </a:rPr>
+              <a:t>UPGRADES</a:t>
+            </a:r>
+          </a:p>
+        </p:txBody>
+      </p:sp>
+      <p:sp>
+        <p:nvSpPr>
+          <p:cNvPr id="8" name="TextBox 7"/>
+          <p:cNvSpPr txBox="1"/>
+          <p:nvPr/>
+        </p:nvSpPr>
+        <p:spPr>
+          <a:xfrm>
+            <a:off x="6400800" y="1627632"/>
+            <a:ext cx="4389120" cy="201168"/>
+          </a:xfrm>
+          <a:prstGeom prst="rect">
+            <a:avLst/>
+          </a:prstGeom>
+          <a:noFill/>
+        </p:spPr>
+        <p:txBody>
+          <a:bodyPr wrap="square" lIns="0" rIns="0" tIns="0" bIns="0" anchor="t">
+            <a:noAutofit/>
+          </a:bodyPr>
+          <a:lstStyle/>
+          <a:p>
+            <a:pPr algn="ctr">
+              <a:lnSpc>
+                <a:spcPct val="100000"/>
+              </a:lnSpc>
+              <a:spcAft>
+                <a:spcPts val="0"/>
+              </a:spcAft>
+            </a:pPr>
+            <a:r>
+              <a:rPr sz="1350" b="1" i="0" spc="80">
+                <a:solidFill>
+                  <a:srgbClr val="6B7280"/>
+                </a:solidFill>
+                <a:latin typeface="Times New Roman"/>
+              </a:rPr>
+              <a:t>DOWNGRADES</a:t>
+            </a:r>
+          </a:p>
+        </p:txBody>
+      </p:sp>
+      <p:sp>
+        <p:nvSpPr>
+          <p:cNvPr id="9" name="Rectangle 8"/>
           <p:cNvSpPr/>
           <p:nvPr/>
         </p:nvSpPr>
         <p:spPr>
           <a:xfrm>
-            <a:off x="7223760" y="1783080"/>
-            <a:ext cx="4297680" cy="1234440"/>
+            <a:off x="1828800" y="1920240"/>
+            <a:ext cx="4389120" cy="1645920"/>
           </a:xfrm>
           <a:prstGeom prst="rect">
             <a:avLst/>
@@ -16693,14 +16881,14 @@
       </p:sp>
       <p:sp>
         <p:nvSpPr>
-          <p:cNvPr id="9" name="Rectangle 8"/>
+          <p:cNvPr id="10" name="Rectangle 9"/>
           <p:cNvSpPr/>
           <p:nvPr/>
         </p:nvSpPr>
         <p:spPr>
           <a:xfrm>
-            <a:off x="7223760" y="1783080"/>
-            <a:ext cx="4297680" cy="50292"/>
+            <a:off x="1828800" y="1920240"/>
+            <a:ext cx="4389120" cy="54864"/>
           </a:xfrm>
           <a:prstGeom prst="rect">
             <a:avLst/>
@@ -16737,14 +16925,14 @@
       </p:sp>
       <p:sp>
         <p:nvSpPr>
-          <p:cNvPr id="10" name="TextBox 9"/>
-          <p:cNvSpPr txBox="1"/>
-          <p:nvPr/>
-        </p:nvSpPr>
-        <p:spPr>
-          <a:xfrm>
-            <a:off x="7406640" y="1911095"/>
-            <a:ext cx="3977640" cy="201168"/>
+          <p:cNvPr id="11" name="TextBox 10"/>
+          <p:cNvSpPr txBox="1"/>
+          <p:nvPr/>
+        </p:nvSpPr>
+        <p:spPr>
+          <a:xfrm>
+            <a:off x="2029968" y="2066544"/>
+            <a:ext cx="3977639" cy="201168"/>
           </a:xfrm>
           <a:prstGeom prst="rect">
             <a:avLst/>
@@ -16766,27 +16954,27 @@
               </a:spcAft>
             </a:pPr>
             <a:r>
-              <a:rPr sz="1282" b="1" i="0" spc="60">
+              <a:rPr sz="1350" b="1" i="0" spc="50">
                 <a:solidFill>
                   <a:srgbClr val="6B7280"/>
                 </a:solidFill>
                 <a:latin typeface="Times New Roman"/>
               </a:rPr>
-              <a:t>STAR MINUS NON-STAR</a:t>
-            </a:r>
-          </a:p>
-        </p:txBody>
-      </p:sp>
-      <p:sp>
-        <p:nvSpPr>
-          <p:cNvPr id="11" name="TextBox 10"/>
-          <p:cNvSpPr txBox="1"/>
-          <p:nvPr/>
-        </p:nvSpPr>
-        <p:spPr>
-          <a:xfrm>
-            <a:off x="7406640" y="2148840"/>
-            <a:ext cx="3977640" cy="502920"/>
+              <a:t>UPGRADE · CAR[-1,+1]</a:t>
+            </a:r>
+          </a:p>
+        </p:txBody>
+      </p:sp>
+      <p:sp>
+        <p:nvSpPr>
+          <p:cNvPr id="12" name="TextBox 11"/>
+          <p:cNvSpPr txBox="1"/>
+          <p:nvPr/>
+        </p:nvSpPr>
+        <p:spPr>
+          <a:xfrm>
+            <a:off x="2029968" y="2359152"/>
+            <a:ext cx="3977639" cy="640080"/>
           </a:xfrm>
           <a:prstGeom prst="rect">
             <a:avLst/>
@@ -16808,7 +16996,7 @@
               </a:spcAft>
             </a:pPr>
             <a:r>
-              <a:rPr sz="4050" b="1" i="0">
+              <a:rPr sz="5130" b="1" i="0">
                 <a:solidFill>
                   <a:srgbClr val="B23A2B"/>
                 </a:solidFill>
@@ -16821,56 +17009,56 @@
       </p:sp>
       <p:sp>
         <p:nvSpPr>
-          <p:cNvPr id="12" name="TextBox 11"/>
-          <p:cNvSpPr txBox="1"/>
-          <p:nvPr/>
-        </p:nvSpPr>
-        <p:spPr>
-          <a:xfrm>
-            <a:off x="7406640" y="2752344"/>
-            <a:ext cx="3977640" cy="173735"/>
-          </a:xfrm>
-          <a:prstGeom prst="rect">
-            <a:avLst/>
-          </a:prstGeom>
-          <a:noFill/>
-        </p:spPr>
-        <p:txBody>
-          <a:bodyPr wrap="square" lIns="0" rIns="0" tIns="0" bIns="0" anchor="t">
-            <a:noAutofit/>
-          </a:bodyPr>
-          <a:lstStyle/>
-          <a:p>
-            <a:pPr algn="l">
-              <a:lnSpc>
-                <a:spcPct val="105000"/>
-              </a:lnSpc>
-              <a:spcAft>
-                <a:spcPts val="0"/>
-              </a:spcAft>
-            </a:pPr>
-            <a:r>
-              <a:rPr sz="1282" b="0" i="0">
+          <p:cNvPr id="13" name="TextBox 12"/>
+          <p:cNvSpPr txBox="1"/>
+          <p:nvPr/>
+        </p:nvSpPr>
+        <p:spPr>
+          <a:xfrm>
+            <a:off x="2029968" y="3063240"/>
+            <a:ext cx="3977639" cy="365760"/>
+          </a:xfrm>
+          <a:prstGeom prst="rect">
+            <a:avLst/>
+          </a:prstGeom>
+          <a:noFill/>
+        </p:spPr>
+        <p:txBody>
+          <a:bodyPr wrap="square" lIns="0" rIns="0" tIns="0" bIns="0" anchor="t">
+            <a:noAutofit/>
+          </a:bodyPr>
+          <a:lstStyle/>
+          <a:p>
+            <a:pPr algn="l">
+              <a:lnSpc>
+                <a:spcPct val="102000"/>
+              </a:lnSpc>
+              <a:spcAft>
+                <a:spcPts val="0"/>
+              </a:spcAft>
+            </a:pPr>
+            <a:r>
+              <a:rPr sz="1417" b="0" i="0">
                 <a:solidFill>
                   <a:srgbClr val="1F2A44"/>
                 </a:solidFill>
                 <a:latin typeface="Times New Roman"/>
               </a:rPr>
-              <a:t>CAR[-1,+1] (t = 2.17)</a:t>
-            </a:r>
-          </a:p>
-        </p:txBody>
-      </p:sp>
-      <p:sp>
-        <p:nvSpPr>
-          <p:cNvPr id="13" name="Rectangle 12"/>
+              <a:t>star minus non-star, t = 2.17</a:t>
+            </a:r>
+          </a:p>
+        </p:txBody>
+      </p:sp>
+      <p:sp>
+        <p:nvSpPr>
+          <p:cNvPr id="14" name="Rectangle 13"/>
           <p:cNvSpPr/>
           <p:nvPr/>
         </p:nvSpPr>
         <p:spPr>
           <a:xfrm>
-            <a:off x="7223760" y="3063239"/>
-            <a:ext cx="4297680" cy="1234440"/>
+            <a:off x="6400800" y="1920240"/>
+            <a:ext cx="4389120" cy="1645920"/>
           </a:xfrm>
           <a:prstGeom prst="rect">
             <a:avLst/>
@@ -16907,14 +17095,14 @@
       </p:sp>
       <p:sp>
         <p:nvSpPr>
-          <p:cNvPr id="14" name="Rectangle 13"/>
+          <p:cNvPr id="15" name="Rectangle 14"/>
           <p:cNvSpPr/>
           <p:nvPr/>
         </p:nvSpPr>
         <p:spPr>
           <a:xfrm>
-            <a:off x="7223760" y="3063239"/>
-            <a:ext cx="4297680" cy="50292"/>
+            <a:off x="6400800" y="1920240"/>
+            <a:ext cx="4389120" cy="54864"/>
           </a:xfrm>
           <a:prstGeom prst="rect">
             <a:avLst/>
@@ -16951,14 +17139,14 @@
       </p:sp>
       <p:sp>
         <p:nvSpPr>
-          <p:cNvPr id="15" name="TextBox 14"/>
-          <p:cNvSpPr txBox="1"/>
-          <p:nvPr/>
-        </p:nvSpPr>
-        <p:spPr>
-          <a:xfrm>
-            <a:off x="7406640" y="3191256"/>
-            <a:ext cx="3977640" cy="201168"/>
+          <p:cNvPr id="16" name="TextBox 15"/>
+          <p:cNvSpPr txBox="1"/>
+          <p:nvPr/>
+        </p:nvSpPr>
+        <p:spPr>
+          <a:xfrm>
+            <a:off x="6601968" y="2066544"/>
+            <a:ext cx="3977639" cy="201168"/>
           </a:xfrm>
           <a:prstGeom prst="rect">
             <a:avLst/>
@@ -16980,27 +17168,27 @@
               </a:spcAft>
             </a:pPr>
             <a:r>
-              <a:rPr sz="1282" b="1" i="0" spc="60">
+              <a:rPr sz="1350" b="1" i="0" spc="50">
                 <a:solidFill>
                   <a:srgbClr val="6B7280"/>
                 </a:solidFill>
                 <a:latin typeface="Times New Roman"/>
               </a:rPr>
-              <a:t>STAR MINUS NON-STAR</a:t>
-            </a:r>
-          </a:p>
-        </p:txBody>
-      </p:sp>
-      <p:sp>
-        <p:nvSpPr>
-          <p:cNvPr id="16" name="TextBox 15"/>
-          <p:cNvSpPr txBox="1"/>
-          <p:nvPr/>
-        </p:nvSpPr>
-        <p:spPr>
-          <a:xfrm>
-            <a:off x="7406640" y="3428999"/>
-            <a:ext cx="3977640" cy="502920"/>
+              <a:t>UPGRADE · ABNORMAL VOLUME</a:t>
+            </a:r>
+          </a:p>
+        </p:txBody>
+      </p:sp>
+      <p:sp>
+        <p:nvSpPr>
+          <p:cNvPr id="17" name="TextBox 16"/>
+          <p:cNvSpPr txBox="1"/>
+          <p:nvPr/>
+        </p:nvSpPr>
+        <p:spPr>
+          <a:xfrm>
+            <a:off x="6601968" y="2359152"/>
+            <a:ext cx="3977639" cy="640080"/>
           </a:xfrm>
           <a:prstGeom prst="rect">
             <a:avLst/>
@@ -17022,69 +17210,69 @@
               </a:spcAft>
             </a:pPr>
             <a:r>
-              <a:rPr sz="4050" b="1" i="0">
+              <a:rPr sz="5130" b="1" i="0">
                 <a:solidFill>
                   <a:srgbClr val="B23A2B"/>
                 </a:solidFill>
                 <a:latin typeface="Times New Roman"/>
               </a:rPr>
-              <a:t>+0.99 pp</a:t>
-            </a:r>
-          </a:p>
-        </p:txBody>
-      </p:sp>
-      <p:sp>
-        <p:nvSpPr>
-          <p:cNvPr id="17" name="TextBox 16"/>
-          <p:cNvSpPr txBox="1"/>
-          <p:nvPr/>
-        </p:nvSpPr>
-        <p:spPr>
-          <a:xfrm>
-            <a:off x="7406640" y="4032503"/>
-            <a:ext cx="3977640" cy="173736"/>
-          </a:xfrm>
-          <a:prstGeom prst="rect">
-            <a:avLst/>
-          </a:prstGeom>
-          <a:noFill/>
-        </p:spPr>
-        <p:txBody>
-          <a:bodyPr wrap="square" lIns="0" rIns="0" tIns="0" bIns="0" anchor="t">
-            <a:noAutofit/>
-          </a:bodyPr>
-          <a:lstStyle/>
-          <a:p>
-            <a:pPr algn="l">
-              <a:lnSpc>
-                <a:spcPct val="105000"/>
-              </a:lnSpc>
-              <a:spcAft>
-                <a:spcPts val="0"/>
-              </a:spcAft>
-            </a:pPr>
-            <a:r>
-              <a:rPr sz="1282" b="0" i="0">
+              <a:t>+0.053</a:t>
+            </a:r>
+          </a:p>
+        </p:txBody>
+      </p:sp>
+      <p:sp>
+        <p:nvSpPr>
+          <p:cNvPr id="18" name="TextBox 17"/>
+          <p:cNvSpPr txBox="1"/>
+          <p:nvPr/>
+        </p:nvSpPr>
+        <p:spPr>
+          <a:xfrm>
+            <a:off x="6601968" y="3063240"/>
+            <a:ext cx="3977639" cy="365760"/>
+          </a:xfrm>
+          <a:prstGeom prst="rect">
+            <a:avLst/>
+          </a:prstGeom>
+          <a:noFill/>
+        </p:spPr>
+        <p:txBody>
+          <a:bodyPr wrap="square" lIns="0" rIns="0" tIns="0" bIns="0" anchor="t">
+            <a:noAutofit/>
+          </a:bodyPr>
+          <a:lstStyle/>
+          <a:p>
+            <a:pPr algn="l">
+              <a:lnSpc>
+                <a:spcPct val="102000"/>
+              </a:lnSpc>
+              <a:spcAft>
+                <a:spcPts val="0"/>
+              </a:spcAft>
+            </a:pPr>
+            <a:r>
+              <a:rPr sz="1417" b="0" i="0">
                 <a:solidFill>
                   <a:srgbClr val="1F2A44"/>
                 </a:solidFill>
                 <a:latin typeface="Times New Roman"/>
               </a:rPr>
-              <a:t>CAR[-5,+5] (t = 3.55)</a:t>
-            </a:r>
-          </a:p>
-        </p:txBody>
-      </p:sp>
-      <p:sp>
-        <p:nvSpPr>
-          <p:cNvPr id="18" name="Rectangle 17"/>
+              <a:t>log points, t = 2.85</a:t>
+            </a:r>
+          </a:p>
+        </p:txBody>
+      </p:sp>
+      <p:sp>
+        <p:nvSpPr>
+          <p:cNvPr id="19" name="Rectangle 18"/>
           <p:cNvSpPr/>
           <p:nvPr/>
         </p:nvSpPr>
         <p:spPr>
           <a:xfrm>
-            <a:off x="7223760" y="4343400"/>
-            <a:ext cx="4297680" cy="1234440"/>
+            <a:off x="1828800" y="3840480"/>
+            <a:ext cx="4389120" cy="1645920"/>
           </a:xfrm>
           <a:prstGeom prst="rect">
             <a:avLst/>
@@ -17121,20 +17309,20 @@
       </p:sp>
       <p:sp>
         <p:nvSpPr>
-          <p:cNvPr id="19" name="Rectangle 18"/>
+          <p:cNvPr id="20" name="Rectangle 19"/>
           <p:cNvSpPr/>
           <p:nvPr/>
         </p:nvSpPr>
         <p:spPr>
           <a:xfrm>
-            <a:off x="7223760" y="4343400"/>
-            <a:ext cx="4297680" cy="50292"/>
+            <a:off x="1828800" y="3840480"/>
+            <a:ext cx="4389120" cy="54864"/>
           </a:xfrm>
           <a:prstGeom prst="rect">
             <a:avLst/>
           </a:prstGeom>
           <a:solidFill>
-            <a:srgbClr val="B23A2B"/>
+            <a:srgbClr val="1F2A44"/>
           </a:solidFill>
           <a:ln>
             <a:noFill/>
@@ -17165,14 +17353,14 @@
       </p:sp>
       <p:sp>
         <p:nvSpPr>
-          <p:cNvPr id="20" name="TextBox 19"/>
-          <p:cNvSpPr txBox="1"/>
-          <p:nvPr/>
-        </p:nvSpPr>
-        <p:spPr>
-          <a:xfrm>
-            <a:off x="7406640" y="4471416"/>
-            <a:ext cx="3977640" cy="201168"/>
+          <p:cNvPr id="21" name="TextBox 20"/>
+          <p:cNvSpPr txBox="1"/>
+          <p:nvPr/>
+        </p:nvSpPr>
+        <p:spPr>
+          <a:xfrm>
+            <a:off x="2029968" y="3986784"/>
+            <a:ext cx="3977639" cy="201168"/>
           </a:xfrm>
           <a:prstGeom prst="rect">
             <a:avLst/>
@@ -17194,27 +17382,27 @@
               </a:spcAft>
             </a:pPr>
             <a:r>
-              <a:rPr sz="1282" b="1" i="0" spc="60">
+              <a:rPr sz="1350" b="1" i="0" spc="50">
                 <a:solidFill>
                   <a:srgbClr val="6B7280"/>
                 </a:solidFill>
                 <a:latin typeface="Times New Roman"/>
               </a:rPr>
-              <a:t>STAR MINUS NON-STAR</a:t>
-            </a:r>
-          </a:p>
-        </p:txBody>
-      </p:sp>
-      <p:sp>
-        <p:nvSpPr>
-          <p:cNvPr id="21" name="TextBox 20"/>
-          <p:cNvSpPr txBox="1"/>
-          <p:nvPr/>
-        </p:nvSpPr>
-        <p:spPr>
-          <a:xfrm>
-            <a:off x="7406640" y="4709160"/>
-            <a:ext cx="3977640" cy="502920"/>
+              <a:t>DOWNGRADE · CAR[-1,+1]</a:t>
+            </a:r>
+          </a:p>
+        </p:txBody>
+      </p:sp>
+      <p:sp>
+        <p:nvSpPr>
+          <p:cNvPr id="22" name="TextBox 21"/>
+          <p:cNvSpPr txBox="1"/>
+          <p:nvPr/>
+        </p:nvSpPr>
+        <p:spPr>
+          <a:xfrm>
+            <a:off x="2029968" y="4279392"/>
+            <a:ext cx="3977639" cy="640080"/>
           </a:xfrm>
           <a:prstGeom prst="rect">
             <a:avLst/>
@@ -17236,105 +17424,318 @@
               </a:spcAft>
             </a:pPr>
             <a:r>
-              <a:rPr sz="4050" b="1" i="0">
+              <a:rPr sz="5130" b="1" i="0">
+                <a:solidFill>
+                  <a:srgbClr val="1F2A44"/>
+                </a:solidFill>
+                <a:latin typeface="Times New Roman"/>
+              </a:rPr>
+              <a:t>+0.06</a:t>
+            </a:r>
+          </a:p>
+        </p:txBody>
+      </p:sp>
+      <p:sp>
+        <p:nvSpPr>
+          <p:cNvPr id="23" name="TextBox 22"/>
+          <p:cNvSpPr txBox="1"/>
+          <p:nvPr/>
+        </p:nvSpPr>
+        <p:spPr>
+          <a:xfrm>
+            <a:off x="2029968" y="4983480"/>
+            <a:ext cx="3977639" cy="365760"/>
+          </a:xfrm>
+          <a:prstGeom prst="rect">
+            <a:avLst/>
+          </a:prstGeom>
+          <a:noFill/>
+        </p:spPr>
+        <p:txBody>
+          <a:bodyPr wrap="square" lIns="0" rIns="0" tIns="0" bIns="0" anchor="t">
+            <a:noAutofit/>
+          </a:bodyPr>
+          <a:lstStyle/>
+          <a:p>
+            <a:pPr algn="l">
+              <a:lnSpc>
+                <a:spcPct val="102000"/>
+              </a:lnSpc>
+              <a:spcAft>
+                <a:spcPts val="0"/>
+              </a:spcAft>
+            </a:pPr>
+            <a:r>
+              <a:rPr sz="1417" b="0" i="0">
+                <a:solidFill>
+                  <a:srgbClr val="1F2A44"/>
+                </a:solidFill>
+                <a:latin typeface="Times New Roman"/>
+              </a:rPr>
+              <a:t>t = 0.35, n.s.</a:t>
+            </a:r>
+          </a:p>
+        </p:txBody>
+      </p:sp>
+      <p:sp>
+        <p:nvSpPr>
+          <p:cNvPr id="24" name="Rectangle 23"/>
+          <p:cNvSpPr/>
+          <p:nvPr/>
+        </p:nvSpPr>
+        <p:spPr>
+          <a:xfrm>
+            <a:off x="6400800" y="3840480"/>
+            <a:ext cx="4389120" cy="1645920"/>
+          </a:xfrm>
+          <a:prstGeom prst="rect">
+            <a:avLst/>
+          </a:prstGeom>
+          <a:solidFill>
+            <a:srgbClr val="F4F1EC"/>
+          </a:solidFill>
+          <a:ln>
+            <a:noFill/>
+          </a:ln>
+          <a:effectLst/>
+        </p:spPr>
+        <p:style>
+          <a:lnRef idx="1">
+            <a:schemeClr val="accent1"/>
+          </a:lnRef>
+          <a:fillRef idx="3">
+            <a:schemeClr val="accent1"/>
+          </a:fillRef>
+          <a:effectRef idx="2">
+            <a:schemeClr val="accent1"/>
+          </a:effectRef>
+          <a:fontRef idx="minor">
+            <a:schemeClr val="lt1"/>
+          </a:fontRef>
+        </p:style>
+        <p:txBody>
+          <a:bodyPr rtlCol="0" anchor="ctr"/>
+          <a:lstStyle/>
+          <a:p>
+            <a:pPr algn="ctr"/>
+          </a:p>
+        </p:txBody>
+      </p:sp>
+      <p:sp>
+        <p:nvSpPr>
+          <p:cNvPr id="25" name="Rectangle 24"/>
+          <p:cNvSpPr/>
+          <p:nvPr/>
+        </p:nvSpPr>
+        <p:spPr>
+          <a:xfrm>
+            <a:off x="6400800" y="3840480"/>
+            <a:ext cx="4389120" cy="54864"/>
+          </a:xfrm>
+          <a:prstGeom prst="rect">
+            <a:avLst/>
+          </a:prstGeom>
+          <a:solidFill>
+            <a:srgbClr val="1F2A44"/>
+          </a:solidFill>
+          <a:ln>
+            <a:noFill/>
+          </a:ln>
+          <a:effectLst/>
+        </p:spPr>
+        <p:style>
+          <a:lnRef idx="1">
+            <a:schemeClr val="accent1"/>
+          </a:lnRef>
+          <a:fillRef idx="3">
+            <a:schemeClr val="accent1"/>
+          </a:fillRef>
+          <a:effectRef idx="2">
+            <a:schemeClr val="accent1"/>
+          </a:effectRef>
+          <a:fontRef idx="minor">
+            <a:schemeClr val="lt1"/>
+          </a:fontRef>
+        </p:style>
+        <p:txBody>
+          <a:bodyPr rtlCol="0" anchor="ctr"/>
+          <a:lstStyle/>
+          <a:p>
+            <a:pPr algn="ctr"/>
+          </a:p>
+        </p:txBody>
+      </p:sp>
+      <p:sp>
+        <p:nvSpPr>
+          <p:cNvPr id="26" name="TextBox 25"/>
+          <p:cNvSpPr txBox="1"/>
+          <p:nvPr/>
+        </p:nvSpPr>
+        <p:spPr>
+          <a:xfrm>
+            <a:off x="6601968" y="3986784"/>
+            <a:ext cx="3977639" cy="201168"/>
+          </a:xfrm>
+          <a:prstGeom prst="rect">
+            <a:avLst/>
+          </a:prstGeom>
+          <a:noFill/>
+        </p:spPr>
+        <p:txBody>
+          <a:bodyPr wrap="square" lIns="0" rIns="0" tIns="0" bIns="0" anchor="t">
+            <a:noAutofit/>
+          </a:bodyPr>
+          <a:lstStyle/>
+          <a:p>
+            <a:pPr algn="l">
+              <a:lnSpc>
+                <a:spcPct val="100000"/>
+              </a:lnSpc>
+              <a:spcAft>
+                <a:spcPts val="0"/>
+              </a:spcAft>
+            </a:pPr>
+            <a:r>
+              <a:rPr sz="1350" b="1" i="0" spc="50">
+                <a:solidFill>
+                  <a:srgbClr val="6B7280"/>
+                </a:solidFill>
+                <a:latin typeface="Times New Roman"/>
+              </a:rPr>
+              <a:t>DOWNGRADE · ABNORMAL VOLUME</a:t>
+            </a:r>
+          </a:p>
+        </p:txBody>
+      </p:sp>
+      <p:sp>
+        <p:nvSpPr>
+          <p:cNvPr id="27" name="TextBox 26"/>
+          <p:cNvSpPr txBox="1"/>
+          <p:nvPr/>
+        </p:nvSpPr>
+        <p:spPr>
+          <a:xfrm>
+            <a:off x="6601968" y="4279392"/>
+            <a:ext cx="3977639" cy="640080"/>
+          </a:xfrm>
+          <a:prstGeom prst="rect">
+            <a:avLst/>
+          </a:prstGeom>
+          <a:noFill/>
+        </p:spPr>
+        <p:txBody>
+          <a:bodyPr wrap="square" lIns="0" rIns="0" tIns="0" bIns="0" anchor="t">
+            <a:noAutofit/>
+          </a:bodyPr>
+          <a:lstStyle/>
+          <a:p>
+            <a:pPr algn="l">
+              <a:lnSpc>
+                <a:spcPct val="100000"/>
+              </a:lnSpc>
+              <a:spcAft>
+                <a:spcPts val="0"/>
+              </a:spcAft>
+            </a:pPr>
+            <a:r>
+              <a:rPr sz="5130" b="1" i="0">
+                <a:solidFill>
+                  <a:srgbClr val="1F2A44"/>
+                </a:solidFill>
+                <a:latin typeface="Times New Roman"/>
+              </a:rPr>
+              <a:t>-0.011</a:t>
+            </a:r>
+          </a:p>
+        </p:txBody>
+      </p:sp>
+      <p:sp>
+        <p:nvSpPr>
+          <p:cNvPr id="28" name="TextBox 27"/>
+          <p:cNvSpPr txBox="1"/>
+          <p:nvPr/>
+        </p:nvSpPr>
+        <p:spPr>
+          <a:xfrm>
+            <a:off x="6601968" y="4983480"/>
+            <a:ext cx="3977639" cy="365760"/>
+          </a:xfrm>
+          <a:prstGeom prst="rect">
+            <a:avLst/>
+          </a:prstGeom>
+          <a:noFill/>
+        </p:spPr>
+        <p:txBody>
+          <a:bodyPr wrap="square" lIns="0" rIns="0" tIns="0" bIns="0" anchor="t">
+            <a:noAutofit/>
+          </a:bodyPr>
+          <a:lstStyle/>
+          <a:p>
+            <a:pPr algn="l">
+              <a:lnSpc>
+                <a:spcPct val="102000"/>
+              </a:lnSpc>
+              <a:spcAft>
+                <a:spcPts val="0"/>
+              </a:spcAft>
+            </a:pPr>
+            <a:r>
+              <a:rPr sz="1417" b="0" i="0">
+                <a:solidFill>
+                  <a:srgbClr val="1F2A44"/>
+                </a:solidFill>
+                <a:latin typeface="Times New Roman"/>
+              </a:rPr>
+              <a:t>log points, t = -0.53, n.s.</a:t>
+            </a:r>
+          </a:p>
+        </p:txBody>
+      </p:sp>
+      <p:sp>
+        <p:nvSpPr>
+          <p:cNvPr id="29" name="TextBox 28"/>
+          <p:cNvSpPr txBox="1"/>
+          <p:nvPr/>
+        </p:nvSpPr>
+        <p:spPr>
+          <a:xfrm>
+            <a:off x="640080" y="5760720"/>
+            <a:ext cx="10881360" cy="365760"/>
+          </a:xfrm>
+          <a:prstGeom prst="rect">
+            <a:avLst/>
+          </a:prstGeom>
+          <a:noFill/>
+        </p:spPr>
+        <p:txBody>
+          <a:bodyPr wrap="square" lIns="0" rIns="0" tIns="0" bIns="0" anchor="t">
+            <a:noAutofit/>
+          </a:bodyPr>
+          <a:lstStyle/>
+          <a:p>
+            <a:pPr algn="l">
+              <a:lnSpc>
+                <a:spcPct val="100000"/>
+              </a:lnSpc>
+              <a:spcAft>
+                <a:spcPts val="0"/>
+              </a:spcAft>
+            </a:pPr>
+            <a:r>
+              <a:rPr sz="1890" b="1" i="0">
                 <a:solidFill>
                   <a:srgbClr val="B23A2B"/>
                 </a:solidFill>
                 <a:latin typeface="Times New Roman"/>
               </a:rPr>
-              <a:t>+0.053</a:t>
-            </a:r>
-          </a:p>
-        </p:txBody>
-      </p:sp>
-      <p:sp>
-        <p:nvSpPr>
-          <p:cNvPr id="22" name="TextBox 21"/>
-          <p:cNvSpPr txBox="1"/>
-          <p:nvPr/>
-        </p:nvSpPr>
-        <p:spPr>
-          <a:xfrm>
-            <a:off x="7406640" y="5312664"/>
-            <a:ext cx="3977640" cy="173735"/>
-          </a:xfrm>
-          <a:prstGeom prst="rect">
-            <a:avLst/>
-          </a:prstGeom>
-          <a:noFill/>
-        </p:spPr>
-        <p:txBody>
-          <a:bodyPr wrap="square" lIns="0" rIns="0" tIns="0" bIns="0" anchor="t">
-            <a:noAutofit/>
-          </a:bodyPr>
-          <a:lstStyle/>
-          <a:p>
-            <a:pPr algn="l">
-              <a:lnSpc>
-                <a:spcPct val="105000"/>
-              </a:lnSpc>
-              <a:spcAft>
-                <a:spcPts val="0"/>
-              </a:spcAft>
-            </a:pPr>
-            <a:r>
-              <a:rPr sz="1282" b="0" i="0">
-                <a:solidFill>
-                  <a:srgbClr val="1F2A44"/>
-                </a:solidFill>
-                <a:latin typeface="Times New Roman"/>
-              </a:rPr>
-              <a:t>AV, log points (t = 2.85)</a:t>
-            </a:r>
-          </a:p>
-        </p:txBody>
-      </p:sp>
-      <p:sp>
-        <p:nvSpPr>
-          <p:cNvPr id="23" name="TextBox 22"/>
-          <p:cNvSpPr txBox="1"/>
-          <p:nvPr/>
-        </p:nvSpPr>
-        <p:spPr>
-          <a:xfrm>
-            <a:off x="7223760" y="5742432"/>
-            <a:ext cx="4297680" cy="502920"/>
-          </a:xfrm>
-          <a:prstGeom prst="rect">
-            <a:avLst/>
-          </a:prstGeom>
-          <a:noFill/>
-        </p:spPr>
-        <p:txBody>
-          <a:bodyPr wrap="square" lIns="0" rIns="0" tIns="0" bIns="0" anchor="t">
-            <a:noAutofit/>
-          </a:bodyPr>
-          <a:lstStyle/>
-          <a:p>
-            <a:pPr algn="l">
-              <a:lnSpc>
-                <a:spcPct val="105000"/>
-              </a:lnSpc>
-              <a:spcAft>
-                <a:spcPts val="0"/>
-              </a:spcAft>
-            </a:pPr>
-            <a:r>
-              <a:rPr sz="1215" b="0" i="0">
-                <a:solidFill>
-                  <a:srgbClr val="6B7280"/>
-                </a:solidFill>
-                <a:latin typeface="Times New Roman"/>
-              </a:rPr>
-              <a:t>Downgrades: +0.06 (t=0.35), -0.19 (t=-0.85), -0.21 (t=-0.74).
-Same-stock-same-day collapse: +0.43 / +0.61 / +1.06; AV +0.059.</a:t>
-            </a:r>
-          </a:p>
-        </p:txBody>
-      </p:sp>
-      <p:sp>
-        <p:nvSpPr>
-          <p:cNvPr id="24" name="TextBox 23"/>
+              <a:t>Price and volume move together, and only for upgrades.</a:t>
+            </a:r>
+          </a:p>
+        </p:txBody>
+      </p:sp>
+      <p:sp>
+        <p:nvSpPr>
+          <p:cNvPr id="30" name="TextBox 29"/>
           <p:cNvSpPr txBox="1"/>
           <p:nvPr/>
         </p:nvSpPr>
@@ -17369,7 +17770,7 @@
                 </a:solidFill>
                 <a:latin typeface="Times New Roman"/>
               </a:rPr>
-              <a:t>Source: iFinD; authors' calculations. Market-adjusted total returns. Bars are star minus non-star; whiskers are 95% CI.</a:t>
+              <a:t>Source: iFinD; authors' calculations. All cells are star minus non-star.</a:t>
             </a:r>
           </a:p>
         </p:txBody>
@@ -17429,7 +17830,7 @@
                 </a:solidFill>
                 <a:latin typeface="Times New Roman"/>
               </a:rPr>
-              <a:t>FINDING 1 · WHERE DOES THE PREMIUM COME FROM?</a:t>
+              <a:t>FINDING 1 · Q1 · WHERE DOES THE CAR PREMIUM COME FROM?</a:t>
             </a:r>
           </a:p>
         </p:txBody>
@@ -17471,7 +17872,7 @@
                 </a:solidFill>
                 <a:latin typeface="Times New Roman"/>
               </a:rPr>
-              <a:t>The short-window premium is concentrated in price-limit events.</a:t>
+              <a:t>The CAR premium is concentrated in price-limit events.</a:t>
             </a:r>
           </a:p>
         </p:txBody>
@@ -17956,8 +18357,8 @@
         </p:nvSpPr>
         <p:spPr>
           <a:xfrm>
-            <a:off x="8412480" y="2926080"/>
-            <a:ext cx="3108960" cy="822960"/>
+            <a:off x="8412480" y="2880360"/>
+            <a:ext cx="3108960" cy="1005840"/>
           </a:xfrm>
           <a:prstGeom prst="rect">
             <a:avLst/>
@@ -17985,7 +18386,7 @@
                 </a:solidFill>
                 <a:latin typeface="Times New Roman"/>
               </a:rPr>
-              <a:t>The 3-day and 5-day premiums lose significance. The 11-day premium remains.</a:t>
+              <a:t>The 3-day and 5-day CAR premiums lose significance. The 11-day CAR premium remains.</a:t>
             </a:r>
           </a:p>
         </p:txBody>
@@ -17993,6 +18394,48 @@
       <p:sp>
         <p:nvSpPr>
           <p:cNvPr id="10" name="TextBox 9"/>
+          <p:cNvSpPr txBox="1"/>
+          <p:nvPr/>
+        </p:nvSpPr>
+        <p:spPr>
+          <a:xfrm>
+            <a:off x="8412480" y="4069080"/>
+            <a:ext cx="3108960" cy="502920"/>
+          </a:xfrm>
+          <a:prstGeom prst="rect">
+            <a:avLst/>
+          </a:prstGeom>
+          <a:noFill/>
+        </p:spPr>
+        <p:txBody>
+          <a:bodyPr wrap="square" lIns="0" rIns="0" tIns="0" bIns="0" anchor="t">
+            <a:noAutofit/>
+          </a:bodyPr>
+          <a:lstStyle/>
+          <a:p>
+            <a:pPr algn="l">
+              <a:lnSpc>
+                <a:spcPct val="100000"/>
+              </a:lnSpc>
+              <a:spcAft>
+                <a:spcPts val="0"/>
+              </a:spcAft>
+            </a:pPr>
+            <a:r>
+              <a:rPr sz="1350" b="0" i="1">
+                <a:solidFill>
+                  <a:srgbClr val="6B7280"/>
+                </a:solidFill>
+                <a:latin typeface="Times New Roman"/>
+              </a:rPr>
+              <a:t>This check covers CAR, not abnormal volume.</a:t>
+            </a:r>
+          </a:p>
+        </p:txBody>
+      </p:sp>
+      <p:sp>
+        <p:nvSpPr>
+          <p:cNvPr id="11" name="TextBox 10"/>
           <p:cNvSpPr txBox="1"/>
           <p:nvPr/>
         </p:nvSpPr>
@@ -18027,7 +18470,49 @@
                 </a:solidFill>
                 <a:latin typeface="Times New Roman"/>
               </a:rPr>
-              <a:t>Only the 11-day window survives. We do not call the 3-day result robust to price limits.</a:t>
+              <a:t>Only the 11-day CAR window survives. We do not call the 3-day CAR result robust to price limits.</a:t>
+            </a:r>
+          </a:p>
+        </p:txBody>
+      </p:sp>
+      <p:sp>
+        <p:nvSpPr>
+          <p:cNvPr id="12" name="TextBox 11"/>
+          <p:cNvSpPr txBox="1"/>
+          <p:nvPr/>
+        </p:nvSpPr>
+        <p:spPr>
+          <a:xfrm>
+            <a:off x="640080" y="6236208"/>
+            <a:ext cx="10881360" cy="228600"/>
+          </a:xfrm>
+          <a:prstGeom prst="rect">
+            <a:avLst/>
+          </a:prstGeom>
+          <a:noFill/>
+        </p:spPr>
+        <p:txBody>
+          <a:bodyPr wrap="square" lIns="0" rIns="0" tIns="0" bIns="0" anchor="t">
+            <a:noAutofit/>
+          </a:bodyPr>
+          <a:lstStyle/>
+          <a:p>
+            <a:pPr algn="l">
+              <a:lnSpc>
+                <a:spcPct val="100000"/>
+              </a:lnSpc>
+              <a:spcAft>
+                <a:spcPts val="0"/>
+              </a:spcAft>
+            </a:pPr>
+            <a:r>
+              <a:rPr sz="1147" b="0" i="0">
+                <a:solidFill>
+                  <a:srgbClr val="6B7280"/>
+                </a:solidFill>
+                <a:latin typeface="Times New Roman"/>
+              </a:rPr>
+              <a:t>Source: iFinD; authors' calculations. Market-adjusted CAR.</a:t>
             </a:r>
           </a:p>
         </p:txBody>
@@ -18087,7 +18572,7 @@
                 </a:solidFill>
                 <a:latin typeface="Times New Roman"/>
               </a:rPr>
-              <a:t>FINDING 2 · DOES THE REACTION PERSIST?</a:t>
+              <a:t>FINDING 2 · Q2 · DRIFT OR REVERSAL?</a:t>
             </a:r>
           </a:p>
         </p:txBody>
@@ -18129,8 +18614,8 @@
                 </a:solidFill>
                 <a:latin typeface="Times New Roman"/>
               </a:rPr>
-              <a:t>Star downgrades keep falling for three months,
-then partially reverse.</a:t>
+              <a:t>Star downgrades drift down, then reverse.
+Star upgrades do not drift.</a:t>
             </a:r>
           </a:p>
         </p:txBody>
@@ -18280,92 +18765,357 @@
       </p:pic>
       <p:sp>
         <p:nvSpPr>
-          <p:cNvPr id="8" name="Rectangle 7"/>
-          <p:cNvSpPr/>
-          <p:nvPr/>
-        </p:nvSpPr>
-        <p:spPr>
-          <a:xfrm>
-            <a:off x="6858000" y="1783080"/>
-            <a:ext cx="4663440" cy="1234440"/>
-          </a:xfrm>
-          <a:prstGeom prst="rect">
-            <a:avLst/>
-          </a:prstGeom>
-          <a:solidFill>
-            <a:srgbClr val="F4F1EC"/>
-          </a:solidFill>
-          <a:ln>
-            <a:noFill/>
-          </a:ln>
-          <a:effectLst/>
-        </p:spPr>
-        <p:style>
-          <a:lnRef idx="1">
-            <a:schemeClr val="accent1"/>
-          </a:lnRef>
-          <a:fillRef idx="3">
-            <a:schemeClr val="accent1"/>
-          </a:fillRef>
-          <a:effectRef idx="2">
-            <a:schemeClr val="accent1"/>
-          </a:effectRef>
-          <a:fontRef idx="minor">
-            <a:schemeClr val="lt1"/>
-          </a:fontRef>
-        </p:style>
-        <p:txBody>
-          <a:bodyPr rtlCol="0" anchor="ctr"/>
-          <a:lstStyle/>
-          <a:p>
-            <a:pPr algn="ctr"/>
-          </a:p>
-        </p:txBody>
-      </p:sp>
-      <p:sp>
-        <p:nvSpPr>
-          <p:cNvPr id="9" name="Rectangle 8"/>
-          <p:cNvSpPr/>
-          <p:nvPr/>
-        </p:nvSpPr>
-        <p:spPr>
-          <a:xfrm>
-            <a:off x="6858000" y="1783080"/>
-            <a:ext cx="4663440" cy="50292"/>
-          </a:xfrm>
-          <a:prstGeom prst="rect">
-            <a:avLst/>
-          </a:prstGeom>
-          <a:solidFill>
-            <a:srgbClr val="B23A2B"/>
-          </a:solidFill>
-          <a:ln>
-            <a:noFill/>
-          </a:ln>
-          <a:effectLst/>
-        </p:spPr>
-        <p:style>
-          <a:lnRef idx="1">
-            <a:schemeClr val="accent1"/>
-          </a:lnRef>
-          <a:fillRef idx="3">
-            <a:schemeClr val="accent1"/>
-          </a:fillRef>
-          <a:effectRef idx="2">
-            <a:schemeClr val="accent1"/>
-          </a:effectRef>
-          <a:fontRef idx="minor">
-            <a:schemeClr val="lt1"/>
-          </a:fontRef>
-        </p:style>
-        <p:txBody>
-          <a:bodyPr rtlCol="0" anchor="ctr"/>
-          <a:lstStyle/>
-          <a:p>
-            <a:pPr algn="ctr"/>
-          </a:p>
-        </p:txBody>
-      </p:sp>
+          <p:cNvPr id="8" name="TextBox 7"/>
+          <p:cNvSpPr txBox="1"/>
+          <p:nvPr/>
+        </p:nvSpPr>
+        <p:spPr>
+          <a:xfrm>
+            <a:off x="6858000" y="1627632"/>
+            <a:ext cx="4663440" cy="201168"/>
+          </a:xfrm>
+          <a:prstGeom prst="rect">
+            <a:avLst/>
+          </a:prstGeom>
+          <a:noFill/>
+        </p:spPr>
+        <p:txBody>
+          <a:bodyPr wrap="square" lIns="0" rIns="0" tIns="0" bIns="0" anchor="t">
+            <a:noAutofit/>
+          </a:bodyPr>
+          <a:lstStyle/>
+          <a:p>
+            <a:pPr algn="l">
+              <a:lnSpc>
+                <a:spcPct val="100000"/>
+              </a:lnSpc>
+              <a:spcAft>
+                <a:spcPts val="0"/>
+              </a:spcAft>
+            </a:pPr>
+            <a:r>
+              <a:rPr sz="1282" b="1" i="0" spc="60">
+                <a:solidFill>
+                  <a:srgbClr val="6B7280"/>
+                </a:solidFill>
+                <a:latin typeface="Times New Roman"/>
+              </a:rPr>
+              <a:t>STAR MINUS NON-STAR CAR</a:t>
+            </a:r>
+          </a:p>
+        </p:txBody>
+      </p:sp>
+      <p:graphicFrame>
+        <p:nvGraphicFramePr>
+          <p:cNvPr id="9" name="Table 8"/>
+          <p:cNvGraphicFramePr>
+            <a:graphicFrameLocks noGrp="1"/>
+          </p:cNvGraphicFramePr>
+          <p:nvPr/>
+        </p:nvGraphicFramePr>
+        <p:xfrm>
+          <a:off x="6858000" y="1874519"/>
+          <a:ext cx="4663440" cy="2926080"/>
+        </p:xfrm>
+        <a:graphic>
+          <a:graphicData uri="http://schemas.openxmlformats.org/drawingml/2006/table">
+            <a:tbl>
+              <a:tblPr>
+                <a:tableStyleId>{5C22544A-7EE6-4342-B048-85BDC9FD1C3A}</a:tableStyleId>
+              </a:tblPr>
+              <a:tblGrid>
+                <a:gridCol w="1280160"/>
+                <a:gridCol w="1691640"/>
+                <a:gridCol w="1691640"/>
+              </a:tblGrid>
+              <a:tr h="731520">
+                <a:tc>
+                  <a:txBody>
+                    <a:bodyPr wrap="square"/>
+                    <a:lstStyle/>
+                    <a:p>
+                      <a:pPr algn="l"/>
+                      <a:r>
+                        <a:rPr sz="1687" b="1">
+                          <a:solidFill>
+                            <a:srgbClr val="FFFFFF"/>
+                          </a:solidFill>
+                          <a:latin typeface="Times New Roman"/>
+                        </a:rPr>
+                        <a:t>Horizon</a:t>
+                      </a:r>
+                    </a:p>
+                  </a:txBody>
+                  <a:tcPr marL="73152" marR="54864" marT="36576" marB="36576" anchor="ctr">
+                    <a:solidFill>
+                      <a:srgbClr val="1F2A44"/>
+                    </a:solidFill>
+                  </a:tcPr>
+                </a:tc>
+                <a:tc>
+                  <a:txBody>
+                    <a:bodyPr wrap="square"/>
+                    <a:lstStyle/>
+                    <a:p>
+                      <a:pPr algn="ctr"/>
+                      <a:r>
+                        <a:rPr sz="1687" b="1">
+                          <a:solidFill>
+                            <a:srgbClr val="FFFFFF"/>
+                          </a:solidFill>
+                          <a:latin typeface="Times New Roman"/>
+                        </a:rPr>
+                        <a:t>Downgrade</a:t>
+                      </a:r>
+                    </a:p>
+                  </a:txBody>
+                  <a:tcPr marL="73152" marR="54864" marT="36576" marB="36576" anchor="ctr">
+                    <a:solidFill>
+                      <a:srgbClr val="1F2A44"/>
+                    </a:solidFill>
+                  </a:tcPr>
+                </a:tc>
+                <a:tc>
+                  <a:txBody>
+                    <a:bodyPr wrap="square"/>
+                    <a:lstStyle/>
+                    <a:p>
+                      <a:pPr algn="ctr"/>
+                      <a:r>
+                        <a:rPr sz="1687" b="1">
+                          <a:solidFill>
+                            <a:srgbClr val="FFFFFF"/>
+                          </a:solidFill>
+                          <a:latin typeface="Times New Roman"/>
+                        </a:rPr>
+                        <a:t>Upgrade</a:t>
+                      </a:r>
+                    </a:p>
+                  </a:txBody>
+                  <a:tcPr marL="73152" marR="54864" marT="36576" marB="36576" anchor="ctr">
+                    <a:solidFill>
+                      <a:srgbClr val="1F2A44"/>
+                    </a:solidFill>
+                  </a:tcPr>
+                </a:tc>
+              </a:tr>
+              <a:tr h="731520">
+                <a:tc>
+                  <a:txBody>
+                    <a:bodyPr wrap="square"/>
+                    <a:lstStyle/>
+                    <a:p>
+                      <a:pPr algn="l"/>
+                      <a:r>
+                        <a:rPr sz="1822" b="0">
+                          <a:solidFill>
+                            <a:srgbClr val="1F2A44"/>
+                          </a:solidFill>
+                          <a:latin typeface="Times New Roman"/>
+                        </a:rPr>
+                        <a:t>+2 to +60</a:t>
+                      </a:r>
+                    </a:p>
+                  </a:txBody>
+                  <a:tcPr marL="73152" marR="54864" marT="36576" marB="36576" anchor="ctr">
+                    <a:solidFill>
+                      <a:srgbClr val="FFFFFF"/>
+                    </a:solidFill>
+                  </a:tcPr>
+                </a:tc>
+                <a:tc>
+                  <a:txBody>
+                    <a:bodyPr wrap="square"/>
+                    <a:lstStyle/>
+                    <a:p>
+                      <a:pPr algn="ctr"/>
+                      <a:r>
+                        <a:rPr sz="1822" b="1">
+                          <a:solidFill>
+                            <a:srgbClr val="B23A2B"/>
+                          </a:solidFill>
+                          <a:latin typeface="Times New Roman"/>
+                        </a:rPr>
+                        <a:t>-1.64 (p=.002)</a:t>
+                      </a:r>
+                    </a:p>
+                  </a:txBody>
+                  <a:tcPr marL="73152" marR="54864" marT="36576" marB="36576" anchor="ctr">
+                    <a:solidFill>
+                      <a:srgbClr val="FFFFFF"/>
+                    </a:solidFill>
+                  </a:tcPr>
+                </a:tc>
+                <a:tc>
+                  <a:txBody>
+                    <a:bodyPr wrap="square"/>
+                    <a:lstStyle/>
+                    <a:p>
+                      <a:pPr algn="ctr"/>
+                      <a:r>
+                        <a:rPr sz="1822" b="1">
+                          <a:solidFill>
+                            <a:srgbClr val="1F2A44"/>
+                          </a:solidFill>
+                          <a:latin typeface="Times New Roman"/>
+                        </a:rPr>
+                        <a:t>-0.07 (p=.90)</a:t>
+                      </a:r>
+                    </a:p>
+                  </a:txBody>
+                  <a:tcPr marL="73152" marR="54864" marT="36576" marB="36576" anchor="ctr">
+                    <a:solidFill>
+                      <a:srgbClr val="FFFFFF"/>
+                    </a:solidFill>
+                  </a:tcPr>
+                </a:tc>
+              </a:tr>
+              <a:tr h="731520">
+                <a:tc>
+                  <a:txBody>
+                    <a:bodyPr wrap="square"/>
+                    <a:lstStyle/>
+                    <a:p>
+                      <a:pPr algn="l"/>
+                      <a:r>
+                        <a:rPr sz="1822" b="0">
+                          <a:solidFill>
+                            <a:srgbClr val="1F2A44"/>
+                          </a:solidFill>
+                          <a:latin typeface="Times New Roman"/>
+                        </a:rPr>
+                        <a:t>+2 to +120</a:t>
+                      </a:r>
+                    </a:p>
+                  </a:txBody>
+                  <a:tcPr marL="73152" marR="54864" marT="36576" marB="36576" anchor="ctr">
+                    <a:solidFill>
+                      <a:srgbClr val="F4F1EC"/>
+                    </a:solidFill>
+                  </a:tcPr>
+                </a:tc>
+                <a:tc>
+                  <a:txBody>
+                    <a:bodyPr wrap="square"/>
+                    <a:lstStyle/>
+                    <a:p>
+                      <a:pPr algn="ctr"/>
+                      <a:r>
+                        <a:rPr sz="1822" b="1">
+                          <a:solidFill>
+                            <a:srgbClr val="B23A2B"/>
+                          </a:solidFill>
+                          <a:latin typeface="Times New Roman"/>
+                        </a:rPr>
+                        <a:t>-0.76 (p=.32)</a:t>
+                      </a:r>
+                    </a:p>
+                  </a:txBody>
+                  <a:tcPr marL="73152" marR="54864" marT="36576" marB="36576" anchor="ctr">
+                    <a:solidFill>
+                      <a:srgbClr val="F4F1EC"/>
+                    </a:solidFill>
+                  </a:tcPr>
+                </a:tc>
+                <a:tc>
+                  <a:txBody>
+                    <a:bodyPr wrap="square"/>
+                    <a:lstStyle/>
+                    <a:p>
+                      <a:pPr algn="ctr"/>
+                      <a:r>
+                        <a:rPr sz="1822" b="1">
+                          <a:solidFill>
+                            <a:srgbClr val="1F2A44"/>
+                          </a:solidFill>
+                          <a:latin typeface="Times New Roman"/>
+                        </a:rPr>
+                        <a:t>+0.98 (p=.16)</a:t>
+                      </a:r>
+                    </a:p>
+                  </a:txBody>
+                  <a:tcPr marL="73152" marR="54864" marT="36576" marB="36576" anchor="ctr">
+                    <a:solidFill>
+                      <a:srgbClr val="F4F1EC"/>
+                    </a:solidFill>
+                  </a:tcPr>
+                </a:tc>
+              </a:tr>
+              <a:tr h="731520">
+                <a:tc>
+                  <a:txBody>
+                    <a:bodyPr wrap="square"/>
+                    <a:lstStyle/>
+                    <a:p>
+                      <a:pPr algn="l"/>
+                      <a:r>
+                        <a:rPr sz="1822" b="0">
+                          <a:solidFill>
+                            <a:srgbClr val="1F2A44"/>
+                          </a:solidFill>
+                          <a:latin typeface="Times New Roman"/>
+                        </a:rPr>
+                        <a:t>+2 to +250</a:t>
+                      </a:r>
+                    </a:p>
+                  </a:txBody>
+                  <a:tcPr marL="73152" marR="54864" marT="36576" marB="36576" anchor="ctr">
+                    <a:solidFill>
+                      <a:srgbClr val="FFFFFF"/>
+                    </a:solidFill>
+                  </a:tcPr>
+                </a:tc>
+                <a:tc>
+                  <a:txBody>
+                    <a:bodyPr wrap="square"/>
+                    <a:lstStyle/>
+                    <a:p>
+                      <a:pPr algn="ctr"/>
+                      <a:r>
+                        <a:rPr sz="1822" b="1">
+                          <a:solidFill>
+                            <a:srgbClr val="B23A2B"/>
+                          </a:solidFill>
+                          <a:latin typeface="Times New Roman"/>
+                        </a:rPr>
+                        <a:t>+1.53 (p=.18)</a:t>
+                      </a:r>
+                    </a:p>
+                  </a:txBody>
+                  <a:tcPr marL="73152" marR="54864" marT="36576" marB="36576" anchor="ctr">
+                    <a:solidFill>
+                      <a:srgbClr val="FFFFFF"/>
+                    </a:solidFill>
+                  </a:tcPr>
+                </a:tc>
+                <a:tc>
+                  <a:txBody>
+                    <a:bodyPr wrap="square"/>
+                    <a:lstStyle/>
+                    <a:p>
+                      <a:pPr algn="ctr"/>
+                      <a:r>
+                        <a:rPr sz="1822" b="1">
+                          <a:solidFill>
+                            <a:srgbClr val="1F2A44"/>
+                          </a:solidFill>
+                          <a:latin typeface="Times New Roman"/>
+                        </a:rPr>
+                        <a:t>+0.76 (p=.48)</a:t>
+                      </a:r>
+                    </a:p>
+                  </a:txBody>
+                  <a:tcPr marL="73152" marR="54864" marT="36576" marB="36576" anchor="ctr">
+                    <a:solidFill>
+                      <a:srgbClr val="FFFFFF"/>
+                    </a:solidFill>
+                  </a:tcPr>
+                </a:tc>
+              </a:tr>
+            </a:tbl>
+          </a:graphicData>
+        </a:graphic>
+      </p:graphicFrame>
       <p:sp>
         <p:nvSpPr>
           <p:cNvPr id="10" name="TextBox 9"/>
@@ -18374,78 +19124,79 @@
         </p:nvSpPr>
         <p:spPr>
           <a:xfrm>
-            <a:off x="7040880" y="1911095"/>
-            <a:ext cx="4343400" cy="201168"/>
-          </a:xfrm>
-          <a:prstGeom prst="rect">
-            <a:avLst/>
-          </a:prstGeom>
-          <a:noFill/>
-        </p:spPr>
-        <p:txBody>
-          <a:bodyPr wrap="square" lIns="0" rIns="0" tIns="0" bIns="0" anchor="t">
-            <a:noAutofit/>
-          </a:bodyPr>
-          <a:lstStyle/>
-          <a:p>
-            <a:pPr algn="l">
-              <a:lnSpc>
-                <a:spcPct val="100000"/>
-              </a:lnSpc>
-              <a:spcAft>
-                <a:spcPts val="0"/>
-              </a:spcAft>
-            </a:pPr>
-            <a:r>
-              <a:rPr sz="1282" b="1" i="0" spc="60">
+            <a:off x="6858000" y="4937760"/>
+            <a:ext cx="4663440" cy="566928"/>
+          </a:xfrm>
+          <a:prstGeom prst="rect">
+            <a:avLst/>
+          </a:prstGeom>
+          <a:noFill/>
+        </p:spPr>
+        <p:txBody>
+          <a:bodyPr wrap="square" lIns="0" rIns="0" tIns="0" bIns="0" anchor="t">
+            <a:noAutofit/>
+          </a:bodyPr>
+          <a:lstStyle/>
+          <a:p>
+            <a:pPr algn="l">
+              <a:lnSpc>
+                <a:spcPct val="105000"/>
+              </a:lnSpc>
+              <a:spcAft>
+                <a:spcPts val="0"/>
+              </a:spcAft>
+            </a:pPr>
+            <a:r>
+              <a:rPr sz="1552" b="1" i="0">
+                <a:solidFill>
+                  <a:srgbClr val="B23A2B"/>
+                </a:solidFill>
+                <a:latin typeface="Times New Roman"/>
+              </a:rPr>
+              <a:t>Downgrades: -1.64 at +60, then +1.53 at +250.
+Upgrades: no differential drift.</a:t>
+            </a:r>
+          </a:p>
+        </p:txBody>
+      </p:sp>
+      <p:sp>
+        <p:nvSpPr>
+          <p:cNvPr id="11" name="TextBox 10"/>
+          <p:cNvSpPr txBox="1"/>
+          <p:nvPr/>
+        </p:nvSpPr>
+        <p:spPr>
+          <a:xfrm>
+            <a:off x="6858000" y="5559552"/>
+            <a:ext cx="4663440" cy="548640"/>
+          </a:xfrm>
+          <a:prstGeom prst="rect">
+            <a:avLst/>
+          </a:prstGeom>
+          <a:noFill/>
+        </p:spPr>
+        <p:txBody>
+          <a:bodyPr wrap="square" lIns="0" rIns="0" tIns="0" bIns="0" anchor="t">
+            <a:noAutofit/>
+          </a:bodyPr>
+          <a:lstStyle/>
+          <a:p>
+            <a:pPr algn="l">
+              <a:lnSpc>
+                <a:spcPct val="105000"/>
+              </a:lnSpc>
+              <a:spcAft>
+                <a:spcPts val="0"/>
+              </a:spcAft>
+            </a:pPr>
+            <a:r>
+              <a:rPr sz="1147" b="0" i="1">
                 <a:solidFill>
                   <a:srgbClr val="6B7280"/>
                 </a:solidFill>
                 <a:latin typeface="Times New Roman"/>
               </a:rPr>
-              <a:t>STAR MINUS NON-STAR</a:t>
-            </a:r>
-          </a:p>
-        </p:txBody>
-      </p:sp>
-      <p:sp>
-        <p:nvSpPr>
-          <p:cNvPr id="11" name="TextBox 10"/>
-          <p:cNvSpPr txBox="1"/>
-          <p:nvPr/>
-        </p:nvSpPr>
-        <p:spPr>
-          <a:xfrm>
-            <a:off x="7040880" y="2148840"/>
-            <a:ext cx="4343400" cy="502920"/>
-          </a:xfrm>
-          <a:prstGeom prst="rect">
-            <a:avLst/>
-          </a:prstGeom>
-          <a:noFill/>
-        </p:spPr>
-        <p:txBody>
-          <a:bodyPr wrap="square" lIns="0" rIns="0" tIns="0" bIns="0" anchor="t">
-            <a:noAutofit/>
-          </a:bodyPr>
-          <a:lstStyle/>
-          <a:p>
-            <a:pPr algn="l">
-              <a:lnSpc>
-                <a:spcPct val="100000"/>
-              </a:lnSpc>
-              <a:spcAft>
-                <a:spcPts val="0"/>
-              </a:spcAft>
-            </a:pPr>
-            <a:r>
-              <a:rPr sz="3780" b="1" i="0">
-                <a:solidFill>
-                  <a:srgbClr val="B23A2B"/>
-                </a:solidFill>
-                <a:latin typeface="Times New Roman"/>
-              </a:rPr>
-              <a:t>-1.64 pp</a:t>
+              <a:t>Consistent with delayed following, not proof of over-following: the downgrade announcement reaction itself is not larger.</a:t>
             </a:r>
           </a:p>
         </p:txBody>
@@ -18453,518 +19204,6 @@
       <p:sp>
         <p:nvSpPr>
           <p:cNvPr id="12" name="TextBox 11"/>
-          <p:cNvSpPr txBox="1"/>
-          <p:nvPr/>
-        </p:nvSpPr>
-        <p:spPr>
-          <a:xfrm>
-            <a:off x="7040880" y="2752344"/>
-            <a:ext cx="4343400" cy="173735"/>
-          </a:xfrm>
-          <a:prstGeom prst="rect">
-            <a:avLst/>
-          </a:prstGeom>
-          <a:noFill/>
-        </p:spPr>
-        <p:txBody>
-          <a:bodyPr wrap="square" lIns="0" rIns="0" tIns="0" bIns="0" anchor="t">
-            <a:noAutofit/>
-          </a:bodyPr>
-          <a:lstStyle/>
-          <a:p>
-            <a:pPr algn="l">
-              <a:lnSpc>
-                <a:spcPct val="105000"/>
-              </a:lnSpc>
-              <a:spcAft>
-                <a:spcPts val="0"/>
-              </a:spcAft>
-            </a:pPr>
-            <a:r>
-              <a:rPr sz="1350" b="0" i="0">
-                <a:solidFill>
-                  <a:srgbClr val="1F2A44"/>
-                </a:solidFill>
-                <a:latin typeface="Times New Roman"/>
-              </a:rPr>
-              <a:t>CAR +2 to +60  (p = 0.002)</a:t>
-            </a:r>
-          </a:p>
-        </p:txBody>
-      </p:sp>
-      <p:sp>
-        <p:nvSpPr>
-          <p:cNvPr id="13" name="Rectangle 12"/>
-          <p:cNvSpPr/>
-          <p:nvPr/>
-        </p:nvSpPr>
-        <p:spPr>
-          <a:xfrm>
-            <a:off x="6858000" y="3081528"/>
-            <a:ext cx="4663440" cy="1234440"/>
-          </a:xfrm>
-          <a:prstGeom prst="rect">
-            <a:avLst/>
-          </a:prstGeom>
-          <a:solidFill>
-            <a:srgbClr val="F4F1EC"/>
-          </a:solidFill>
-          <a:ln>
-            <a:noFill/>
-          </a:ln>
-          <a:effectLst/>
-        </p:spPr>
-        <p:style>
-          <a:lnRef idx="1">
-            <a:schemeClr val="accent1"/>
-          </a:lnRef>
-          <a:fillRef idx="3">
-            <a:schemeClr val="accent1"/>
-          </a:fillRef>
-          <a:effectRef idx="2">
-            <a:schemeClr val="accent1"/>
-          </a:effectRef>
-          <a:fontRef idx="minor">
-            <a:schemeClr val="lt1"/>
-          </a:fontRef>
-        </p:style>
-        <p:txBody>
-          <a:bodyPr rtlCol="0" anchor="ctr"/>
-          <a:lstStyle/>
-          <a:p>
-            <a:pPr algn="ctr"/>
-          </a:p>
-        </p:txBody>
-      </p:sp>
-      <p:sp>
-        <p:nvSpPr>
-          <p:cNvPr id="14" name="Rectangle 13"/>
-          <p:cNvSpPr/>
-          <p:nvPr/>
-        </p:nvSpPr>
-        <p:spPr>
-          <a:xfrm>
-            <a:off x="6858000" y="3081528"/>
-            <a:ext cx="4663440" cy="50292"/>
-          </a:xfrm>
-          <a:prstGeom prst="rect">
-            <a:avLst/>
-          </a:prstGeom>
-          <a:solidFill>
-            <a:srgbClr val="B23A2B"/>
-          </a:solidFill>
-          <a:ln>
-            <a:noFill/>
-          </a:ln>
-          <a:effectLst/>
-        </p:spPr>
-        <p:style>
-          <a:lnRef idx="1">
-            <a:schemeClr val="accent1"/>
-          </a:lnRef>
-          <a:fillRef idx="3">
-            <a:schemeClr val="accent1"/>
-          </a:fillRef>
-          <a:effectRef idx="2">
-            <a:schemeClr val="accent1"/>
-          </a:effectRef>
-          <a:fontRef idx="minor">
-            <a:schemeClr val="lt1"/>
-          </a:fontRef>
-        </p:style>
-        <p:txBody>
-          <a:bodyPr rtlCol="0" anchor="ctr"/>
-          <a:lstStyle/>
-          <a:p>
-            <a:pPr algn="ctr"/>
-          </a:p>
-        </p:txBody>
-      </p:sp>
-      <p:sp>
-        <p:nvSpPr>
-          <p:cNvPr id="15" name="TextBox 14"/>
-          <p:cNvSpPr txBox="1"/>
-          <p:nvPr/>
-        </p:nvSpPr>
-        <p:spPr>
-          <a:xfrm>
-            <a:off x="7040880" y="3209544"/>
-            <a:ext cx="4343400" cy="201168"/>
-          </a:xfrm>
-          <a:prstGeom prst="rect">
-            <a:avLst/>
-          </a:prstGeom>
-          <a:noFill/>
-        </p:spPr>
-        <p:txBody>
-          <a:bodyPr wrap="square" lIns="0" rIns="0" tIns="0" bIns="0" anchor="t">
-            <a:noAutofit/>
-          </a:bodyPr>
-          <a:lstStyle/>
-          <a:p>
-            <a:pPr algn="l">
-              <a:lnSpc>
-                <a:spcPct val="100000"/>
-              </a:lnSpc>
-              <a:spcAft>
-                <a:spcPts val="0"/>
-              </a:spcAft>
-            </a:pPr>
-            <a:r>
-              <a:rPr sz="1282" b="1" i="0" spc="60">
-                <a:solidFill>
-                  <a:srgbClr val="6B7280"/>
-                </a:solidFill>
-                <a:latin typeface="Times New Roman"/>
-              </a:rPr>
-              <a:t>STAR MINUS NON-STAR</a:t>
-            </a:r>
-          </a:p>
-        </p:txBody>
-      </p:sp>
-      <p:sp>
-        <p:nvSpPr>
-          <p:cNvPr id="16" name="TextBox 15"/>
-          <p:cNvSpPr txBox="1"/>
-          <p:nvPr/>
-        </p:nvSpPr>
-        <p:spPr>
-          <a:xfrm>
-            <a:off x="7040880" y="3447288"/>
-            <a:ext cx="4343400" cy="502920"/>
-          </a:xfrm>
-          <a:prstGeom prst="rect">
-            <a:avLst/>
-          </a:prstGeom>
-          <a:noFill/>
-        </p:spPr>
-        <p:txBody>
-          <a:bodyPr wrap="square" lIns="0" rIns="0" tIns="0" bIns="0" anchor="t">
-            <a:noAutofit/>
-          </a:bodyPr>
-          <a:lstStyle/>
-          <a:p>
-            <a:pPr algn="l">
-              <a:lnSpc>
-                <a:spcPct val="100000"/>
-              </a:lnSpc>
-              <a:spcAft>
-                <a:spcPts val="0"/>
-              </a:spcAft>
-            </a:pPr>
-            <a:r>
-              <a:rPr sz="3780" b="1" i="0">
-                <a:solidFill>
-                  <a:srgbClr val="B23A2B"/>
-                </a:solidFill>
-                <a:latin typeface="Times New Roman"/>
-              </a:rPr>
-              <a:t>-0.76 pp</a:t>
-            </a:r>
-          </a:p>
-        </p:txBody>
-      </p:sp>
-      <p:sp>
-        <p:nvSpPr>
-          <p:cNvPr id="17" name="TextBox 16"/>
-          <p:cNvSpPr txBox="1"/>
-          <p:nvPr/>
-        </p:nvSpPr>
-        <p:spPr>
-          <a:xfrm>
-            <a:off x="7040880" y="4050791"/>
-            <a:ext cx="4343400" cy="173736"/>
-          </a:xfrm>
-          <a:prstGeom prst="rect">
-            <a:avLst/>
-          </a:prstGeom>
-          <a:noFill/>
-        </p:spPr>
-        <p:txBody>
-          <a:bodyPr wrap="square" lIns="0" rIns="0" tIns="0" bIns="0" anchor="t">
-            <a:noAutofit/>
-          </a:bodyPr>
-          <a:lstStyle/>
-          <a:p>
-            <a:pPr algn="l">
-              <a:lnSpc>
-                <a:spcPct val="105000"/>
-              </a:lnSpc>
-              <a:spcAft>
-                <a:spcPts val="0"/>
-              </a:spcAft>
-            </a:pPr>
-            <a:r>
-              <a:rPr sz="1350" b="0" i="0">
-                <a:solidFill>
-                  <a:srgbClr val="1F2A44"/>
-                </a:solidFill>
-                <a:latin typeface="Times New Roman"/>
-              </a:rPr>
-              <a:t>CAR +2 to +120  (p = 0.32)</a:t>
-            </a:r>
-          </a:p>
-        </p:txBody>
-      </p:sp>
-      <p:sp>
-        <p:nvSpPr>
-          <p:cNvPr id="18" name="Rectangle 17"/>
-          <p:cNvSpPr/>
-          <p:nvPr/>
-        </p:nvSpPr>
-        <p:spPr>
-          <a:xfrm>
-            <a:off x="6858000" y="4379976"/>
-            <a:ext cx="4663440" cy="1234440"/>
-          </a:xfrm>
-          <a:prstGeom prst="rect">
-            <a:avLst/>
-          </a:prstGeom>
-          <a:solidFill>
-            <a:srgbClr val="F4F1EC"/>
-          </a:solidFill>
-          <a:ln>
-            <a:noFill/>
-          </a:ln>
-          <a:effectLst/>
-        </p:spPr>
-        <p:style>
-          <a:lnRef idx="1">
-            <a:schemeClr val="accent1"/>
-          </a:lnRef>
-          <a:fillRef idx="3">
-            <a:schemeClr val="accent1"/>
-          </a:fillRef>
-          <a:effectRef idx="2">
-            <a:schemeClr val="accent1"/>
-          </a:effectRef>
-          <a:fontRef idx="minor">
-            <a:schemeClr val="lt1"/>
-          </a:fontRef>
-        </p:style>
-        <p:txBody>
-          <a:bodyPr rtlCol="0" anchor="ctr"/>
-          <a:lstStyle/>
-          <a:p>
-            <a:pPr algn="ctr"/>
-          </a:p>
-        </p:txBody>
-      </p:sp>
-      <p:sp>
-        <p:nvSpPr>
-          <p:cNvPr id="19" name="Rectangle 18"/>
-          <p:cNvSpPr/>
-          <p:nvPr/>
-        </p:nvSpPr>
-        <p:spPr>
-          <a:xfrm>
-            <a:off x="6858000" y="4379976"/>
-            <a:ext cx="4663440" cy="50292"/>
-          </a:xfrm>
-          <a:prstGeom prst="rect">
-            <a:avLst/>
-          </a:prstGeom>
-          <a:solidFill>
-            <a:srgbClr val="1F2A44"/>
-          </a:solidFill>
-          <a:ln>
-            <a:noFill/>
-          </a:ln>
-          <a:effectLst/>
-        </p:spPr>
-        <p:style>
-          <a:lnRef idx="1">
-            <a:schemeClr val="accent1"/>
-          </a:lnRef>
-          <a:fillRef idx="3">
-            <a:schemeClr val="accent1"/>
-          </a:fillRef>
-          <a:effectRef idx="2">
-            <a:schemeClr val="accent1"/>
-          </a:effectRef>
-          <a:fontRef idx="minor">
-            <a:schemeClr val="lt1"/>
-          </a:fontRef>
-        </p:style>
-        <p:txBody>
-          <a:bodyPr rtlCol="0" anchor="ctr"/>
-          <a:lstStyle/>
-          <a:p>
-            <a:pPr algn="ctr"/>
-          </a:p>
-        </p:txBody>
-      </p:sp>
-      <p:sp>
-        <p:nvSpPr>
-          <p:cNvPr id="20" name="TextBox 19"/>
-          <p:cNvSpPr txBox="1"/>
-          <p:nvPr/>
-        </p:nvSpPr>
-        <p:spPr>
-          <a:xfrm>
-            <a:off x="7040880" y="4507992"/>
-            <a:ext cx="4343400" cy="201168"/>
-          </a:xfrm>
-          <a:prstGeom prst="rect">
-            <a:avLst/>
-          </a:prstGeom>
-          <a:noFill/>
-        </p:spPr>
-        <p:txBody>
-          <a:bodyPr wrap="square" lIns="0" rIns="0" tIns="0" bIns="0" anchor="t">
-            <a:noAutofit/>
-          </a:bodyPr>
-          <a:lstStyle/>
-          <a:p>
-            <a:pPr algn="l">
-              <a:lnSpc>
-                <a:spcPct val="100000"/>
-              </a:lnSpc>
-              <a:spcAft>
-                <a:spcPts val="0"/>
-              </a:spcAft>
-            </a:pPr>
-            <a:r>
-              <a:rPr sz="1282" b="1" i="0" spc="60">
-                <a:solidFill>
-                  <a:srgbClr val="6B7280"/>
-                </a:solidFill>
-                <a:latin typeface="Times New Roman"/>
-              </a:rPr>
-              <a:t>STAR MINUS NON-STAR</a:t>
-            </a:r>
-          </a:p>
-        </p:txBody>
-      </p:sp>
-      <p:sp>
-        <p:nvSpPr>
-          <p:cNvPr id="21" name="TextBox 20"/>
-          <p:cNvSpPr txBox="1"/>
-          <p:nvPr/>
-        </p:nvSpPr>
-        <p:spPr>
-          <a:xfrm>
-            <a:off x="7040880" y="4745736"/>
-            <a:ext cx="4343400" cy="502920"/>
-          </a:xfrm>
-          <a:prstGeom prst="rect">
-            <a:avLst/>
-          </a:prstGeom>
-          <a:noFill/>
-        </p:spPr>
-        <p:txBody>
-          <a:bodyPr wrap="square" lIns="0" rIns="0" tIns="0" bIns="0" anchor="t">
-            <a:noAutofit/>
-          </a:bodyPr>
-          <a:lstStyle/>
-          <a:p>
-            <a:pPr algn="l">
-              <a:lnSpc>
-                <a:spcPct val="100000"/>
-              </a:lnSpc>
-              <a:spcAft>
-                <a:spcPts val="0"/>
-              </a:spcAft>
-            </a:pPr>
-            <a:r>
-              <a:rPr sz="3780" b="1" i="0">
-                <a:solidFill>
-                  <a:srgbClr val="1F2A44"/>
-                </a:solidFill>
-                <a:latin typeface="Times New Roman"/>
-              </a:rPr>
-              <a:t>+1.53 pp</a:t>
-            </a:r>
-          </a:p>
-        </p:txBody>
-      </p:sp>
-      <p:sp>
-        <p:nvSpPr>
-          <p:cNvPr id="22" name="TextBox 21"/>
-          <p:cNvSpPr txBox="1"/>
-          <p:nvPr/>
-        </p:nvSpPr>
-        <p:spPr>
-          <a:xfrm>
-            <a:off x="7040880" y="5349240"/>
-            <a:ext cx="4343400" cy="173735"/>
-          </a:xfrm>
-          <a:prstGeom prst="rect">
-            <a:avLst/>
-          </a:prstGeom>
-          <a:noFill/>
-        </p:spPr>
-        <p:txBody>
-          <a:bodyPr wrap="square" lIns="0" rIns="0" tIns="0" bIns="0" anchor="t">
-            <a:noAutofit/>
-          </a:bodyPr>
-          <a:lstStyle/>
-          <a:p>
-            <a:pPr algn="l">
-              <a:lnSpc>
-                <a:spcPct val="105000"/>
-              </a:lnSpc>
-              <a:spcAft>
-                <a:spcPts val="0"/>
-              </a:spcAft>
-            </a:pPr>
-            <a:r>
-              <a:rPr sz="1350" b="0" i="0">
-                <a:solidFill>
-                  <a:srgbClr val="1F2A44"/>
-                </a:solidFill>
-                <a:latin typeface="Times New Roman"/>
-              </a:rPr>
-              <a:t>CAR +2 to +250  (p = 0.18)</a:t>
-            </a:r>
-          </a:p>
-        </p:txBody>
-      </p:sp>
-      <p:sp>
-        <p:nvSpPr>
-          <p:cNvPr id="23" name="TextBox 22"/>
-          <p:cNvSpPr txBox="1"/>
-          <p:nvPr/>
-        </p:nvSpPr>
-        <p:spPr>
-          <a:xfrm>
-            <a:off x="6858000" y="5715000"/>
-            <a:ext cx="4663440" cy="274320"/>
-          </a:xfrm>
-          <a:prstGeom prst="rect">
-            <a:avLst/>
-          </a:prstGeom>
-          <a:noFill/>
-        </p:spPr>
-        <p:txBody>
-          <a:bodyPr wrap="square" lIns="0" rIns="0" tIns="0" bIns="0" anchor="t">
-            <a:noAutofit/>
-          </a:bodyPr>
-          <a:lstStyle/>
-          <a:p>
-            <a:pPr algn="l">
-              <a:lnSpc>
-                <a:spcPct val="100000"/>
-              </a:lnSpc>
-              <a:spcAft>
-                <a:spcPts val="0"/>
-              </a:spcAft>
-            </a:pPr>
-            <a:r>
-              <a:rPr sz="1485" b="0" i="0">
-                <a:solidFill>
-                  <a:srgbClr val="6B7280"/>
-                </a:solidFill>
-                <a:latin typeface="Times New Roman"/>
-              </a:rPr>
-              <a:t>Upgrades: -0.07 / +0.98 / +0.76, all insignificant.</a:t>
-            </a:r>
-          </a:p>
-        </p:txBody>
-      </p:sp>
-      <p:sp>
-        <p:nvSpPr>
-          <p:cNvPr id="24" name="TextBox 23"/>
           <p:cNvSpPr txBox="1"/>
           <p:nvPr/>
         </p:nvSpPr>
@@ -18999,7 +19238,7 @@
                 </a:solidFill>
                 <a:latin typeface="Times New Roman"/>
               </a:rPr>
-              <a:t>Source: iFinD; authors' calculations. Market-adjusted CAR from +2. Bars are star minus non-star; whiskers are 95% CI.</a:t>
+              <a:t>Source: iFinD; authors' calculations. Market-adjusted CAR from +2.</a:t>
             </a:r>
           </a:p>
         </p:txBody>

</xml_diff>

<commit_message>
Clarify that Q3 is one of four tests
Slide 3 now frames Q1-Q4 as four tests of one question. Finding 3 asks only the measurable accuracy question; the information-versus-influence verdict stays on the interpretation slide. Updates the written backup's question hierarchy.

Co-Authored-By: Claude Fable 5.1 <noreply@anthropic.com>
</commit_message>
<xml_diff>
--- a/文档/Project10_Star_Analyst_Deck_20261027.pptx
+++ b/文档/Project10_Star_Analyst_Deck_20261027.pptx
@@ -5132,7 +5132,7 @@
                 </a:solidFill>
                 <a:latin typeface="Times New Roman"/>
               </a:rPr>
-              <a:t>FINDING 3 · Q3 · MORE ACCURATE OR JUST INFLUENTIAL?</a:t>
+              <a:t>FINDING 3 · Q3 · ARE STARS MORE ACCURATE EX POST?</a:t>
             </a:r>
           </a:p>
         </p:txBody>
@@ -11862,7 +11862,7 @@
                 </a:solidFill>
                 <a:latin typeface="Times New Roman"/>
               </a:rPr>
-              <a:t>MECHANISM AND HYPOTHESES</a:t>
+              <a:t>ONE QUESTION, FOUR TESTS</a:t>
             </a:r>
           </a:p>
         </p:txBody>
@@ -13571,6 +13571,48 @@
       <p:sp>
         <p:nvSpPr>
           <p:cNvPr id="42" name="TextBox 41"/>
+          <p:cNvSpPr txBox="1"/>
+          <p:nvPr/>
+        </p:nvSpPr>
+        <p:spPr>
+          <a:xfrm>
+            <a:off x="640080" y="5257800"/>
+            <a:ext cx="10881360" cy="274320"/>
+          </a:xfrm>
+          <a:prstGeom prst="rect">
+            <a:avLst/>
+          </a:prstGeom>
+          <a:noFill/>
+        </p:spPr>
+        <p:txBody>
+          <a:bodyPr wrap="square" lIns="0" rIns="0" tIns="0" bIns="0" anchor="t">
+            <a:noAutofit/>
+          </a:bodyPr>
+          <a:lstStyle/>
+          <a:p>
+            <a:pPr algn="l">
+              <a:lnSpc>
+                <a:spcPct val="100000"/>
+              </a:lnSpc>
+              <a:spcAft>
+                <a:spcPts val="0"/>
+              </a:spcAft>
+            </a:pPr>
+            <a:r>
+              <a:rPr sz="1282" b="0" i="1">
+                <a:solidFill>
+                  <a:srgbClr val="6B7280"/>
+                </a:solidFill>
+                <a:latin typeface="Times New Roman"/>
+              </a:rPr>
+              <a:t>Q1 to Q4 are four tests of this contrast, not four separate questions.</a:t>
+            </a:r>
+          </a:p>
+        </p:txBody>
+      </p:sp>
+      <p:sp>
+        <p:nvSpPr>
+          <p:cNvPr id="43" name="TextBox 42"/>
           <p:cNvSpPr txBox="1"/>
           <p:nvPr/>
         </p:nvSpPr>

</xml_diff>